<commit_message>
Revert to stable bordered layout, fix messy排版
Restore clean centered frame design from earlier version.
Simplify knowledge slides (keyword|content table, no overlapping badges).
Keep only 5 PPTs: lessons 21-24 + showcase.

Co-authored-by: Lin Silentium <decemberlin54-del@users.noreply.github.com>
</commit_message>
<xml_diff>
--- a/unit6-showcase.pptx
+++ b/unit6-showcase.pptx
@@ -3095,7 +3095,7 @@
       <p:grpSpPr/>
       <p:pic>
         <p:nvPicPr>
-          <p:cNvPr id="2" name="Picture 1" descr="bg_show.png"/>
+          <p:cNvPr id="2" name="Picture 1" descr="bg_final.png"/>
           <p:cNvPicPr>
             <a:picLocks noChangeAspect="1"/>
           </p:cNvPicPr>
@@ -3132,9 +3132,9 @@
             <a:avLst/>
           </a:prstGeom>
           <a:noFill/>
-          <a:ln w="25400">
+          <a:ln w="31750">
             <a:solidFill>
-              <a:srgbClr val="784696"/>
+              <a:srgbClr val="B464B4"/>
             </a:solidFill>
           </a:ln>
         </p:spPr>
@@ -3160,181 +3160,73 @@
           </a:p>
         </p:txBody>
       </p:sp>
-      <p:sp>
-        <p:nvSpPr>
-          <p:cNvPr id="4" name="TextBox 3"/>
-          <p:cNvSpPr txBox="1"/>
-          <p:nvPr/>
-        </p:nvSpPr>
-        <p:spPr>
-          <a:xfrm>
-            <a:off x="4114800" y="1371600"/>
-            <a:ext cx="1371600" cy="1371600"/>
+      <p:pic>
+        <p:nvPicPr>
+          <p:cNvPr id="4" name="Picture 3" descr="corner_final_tl.png"/>
+          <p:cNvPicPr>
+            <a:picLocks noChangeAspect="1"/>
+          </p:cNvPicPr>
+          <p:nvPr/>
+        </p:nvPicPr>
+        <p:blipFill>
+          <a:blip r:embed="rId3"/>
+          <a:stretch>
+            <a:fillRect/>
+          </a:stretch>
+        </p:blipFill>
+        <p:spPr>
+          <a:xfrm>
+            <a:off x="-45720" y="-45720"/>
+            <a:ext cx="2011680" cy="2011680"/>
+          </a:xfrm>
+          <a:prstGeom prst="rect">
+            <a:avLst/>
+          </a:prstGeom>
+        </p:spPr>
+      </p:pic>
+      <p:pic>
+        <p:nvPicPr>
+          <p:cNvPr id="5" name="Picture 4" descr="corner_final_tr.png"/>
+          <p:cNvPicPr>
+            <a:picLocks noChangeAspect="1"/>
+          </p:cNvPicPr>
+          <p:nvPr/>
+        </p:nvPicPr>
+        <p:blipFill>
+          <a:blip r:embed="rId4"/>
+          <a:stretch>
+            <a:fillRect/>
+          </a:stretch>
+        </p:blipFill>
+        <p:spPr>
+          <a:xfrm>
+            <a:off x="9875520" y="-45720"/>
+            <a:ext cx="2011680" cy="2011680"/>
+          </a:xfrm>
+          <a:prstGeom prst="rect">
+            <a:avLst/>
+          </a:prstGeom>
+        </p:spPr>
+      </p:pic>
+      <p:sp>
+        <p:nvSpPr>
+          <p:cNvPr id="6" name="Rectangle 5"/>
+          <p:cNvSpPr/>
+          <p:nvPr/>
+        </p:nvSpPr>
+        <p:spPr>
+          <a:xfrm>
+            <a:off x="292608" y="274320"/>
+            <a:ext cx="11594592" cy="6300216"/>
           </a:xfrm>
           <a:prstGeom prst="rect">
             <a:avLst/>
           </a:prstGeom>
           <a:noFill/>
-        </p:spPr>
-        <p:txBody>
-          <a:bodyPr wrap="none">
-            <a:spAutoFit/>
-          </a:bodyPr>
-          <a:lstStyle/>
-          <a:p>
-            <a:pPr algn="ctr">
-              <a:spcAft>
-                <a:spcPts val="800"/>
-              </a:spcAft>
-            </a:pPr>
-            <a:r>
-              <a:rPr sz="8000" b="1">
-                <a:solidFill>
-                  <a:srgbClr val="784696"/>
-                </a:solidFill>
-                <a:latin typeface="Microsoft YaHei"/>
-              </a:rPr>
-              <a:t>想</a:t>
-            </a:r>
-          </a:p>
-        </p:txBody>
-      </p:sp>
-      <p:sp>
-        <p:nvSpPr>
-          <p:cNvPr id="5" name="TextBox 4"/>
-          <p:cNvSpPr txBox="1"/>
-          <p:nvPr/>
-        </p:nvSpPr>
-        <p:spPr>
-          <a:xfrm>
-            <a:off x="5303520" y="1371600"/>
-            <a:ext cx="1371600" cy="1371600"/>
-          </a:xfrm>
-          <a:prstGeom prst="rect">
-            <a:avLst/>
-          </a:prstGeom>
-          <a:noFill/>
-        </p:spPr>
-        <p:txBody>
-          <a:bodyPr wrap="none">
-            <a:spAutoFit/>
-          </a:bodyPr>
-          <a:lstStyle/>
-          <a:p>
-            <a:pPr algn="ctr">
-              <a:spcAft>
-                <a:spcPts val="800"/>
-              </a:spcAft>
-            </a:pPr>
-            <a:r>
-              <a:rPr sz="8000" b="1">
-                <a:solidFill>
-                  <a:srgbClr val="784696"/>
-                </a:solidFill>
-                <a:latin typeface="Microsoft YaHei"/>
-              </a:rPr>
-              <a:t>象</a:t>
-            </a:r>
-          </a:p>
-        </p:txBody>
-      </p:sp>
-      <p:sp>
-        <p:nvSpPr>
-          <p:cNvPr id="6" name="TextBox 5"/>
-          <p:cNvSpPr txBox="1"/>
-          <p:nvPr/>
-        </p:nvSpPr>
-        <p:spPr>
-          <a:xfrm>
-            <a:off x="6492240" y="1371600"/>
-            <a:ext cx="1371600" cy="1371600"/>
-          </a:xfrm>
-          <a:prstGeom prst="rect">
-            <a:avLst/>
-          </a:prstGeom>
-          <a:noFill/>
-        </p:spPr>
-        <p:txBody>
-          <a:bodyPr wrap="none">
-            <a:spAutoFit/>
-          </a:bodyPr>
-          <a:lstStyle/>
-          <a:p>
-            <a:pPr algn="ctr">
-              <a:spcAft>
-                <a:spcPts val="800"/>
-              </a:spcAft>
-            </a:pPr>
-            <a:r>
-              <a:rPr sz="8000" b="1">
-                <a:solidFill>
-                  <a:srgbClr val="784696"/>
-                </a:solidFill>
-                <a:latin typeface="Microsoft YaHei"/>
-              </a:rPr>
-              <a:t>力</a:t>
-            </a:r>
-          </a:p>
-        </p:txBody>
-      </p:sp>
-      <p:sp>
-        <p:nvSpPr>
-          <p:cNvPr id="7" name="TextBox 6"/>
-          <p:cNvSpPr txBox="1"/>
-          <p:nvPr/>
-        </p:nvSpPr>
-        <p:spPr>
-          <a:xfrm>
-            <a:off x="3200400" y="4114800"/>
-            <a:ext cx="5760720" cy="731520"/>
-          </a:xfrm>
-          <a:prstGeom prst="rect">
-            <a:avLst/>
-          </a:prstGeom>
-          <a:noFill/>
-        </p:spPr>
-        <p:txBody>
-          <a:bodyPr wrap="none">
-            <a:spAutoFit/>
-          </a:bodyPr>
-          <a:lstStyle/>
-          <a:p>
-            <a:pPr algn="ctr">
-              <a:spcAft>
-                <a:spcPts val="800"/>
-              </a:spcAft>
-            </a:pPr>
-            <a:r>
-              <a:rPr sz="2800" b="0">
-                <a:solidFill>
-                  <a:srgbClr val="321E46"/>
-                </a:solidFill>
-                <a:latin typeface="Microsoft YaHei"/>
-              </a:rPr>
-              <a:t>第七单元学历案 · 成果展示</a:t>
-            </a:r>
-          </a:p>
-        </p:txBody>
-      </p:sp>
-      <p:sp>
-        <p:nvSpPr>
-          <p:cNvPr id="8" name="Oval 7"/>
-          <p:cNvSpPr/>
-          <p:nvPr/>
-        </p:nvSpPr>
-        <p:spPr>
-          <a:xfrm>
-            <a:off x="1645920" y="5029200"/>
-            <a:ext cx="411480" cy="411480"/>
-          </a:xfrm>
-          <a:prstGeom prst="ellipse">
-            <a:avLst/>
-          </a:prstGeom>
-          <a:solidFill>
-            <a:srgbClr val="E66496"/>
-          </a:solidFill>
-          <a:ln>
-            <a:noFill/>
+          <a:ln w="31750">
+            <a:solidFill>
+              <a:srgbClr val="B464B4"/>
+            </a:solidFill>
           </a:ln>
         </p:spPr>
         <p:style>
@@ -3361,101 +3253,23 @@
       </p:sp>
       <p:sp>
         <p:nvSpPr>
-          <p:cNvPr id="9" name="TextBox 8"/>
-          <p:cNvSpPr txBox="1"/>
-          <p:nvPr/>
-        </p:nvSpPr>
-        <p:spPr>
-          <a:xfrm>
-            <a:off x="1645920" y="5056632"/>
-            <a:ext cx="411480" cy="384048"/>
+          <p:cNvPr id="7" name="Rectangle 6"/>
+          <p:cNvSpPr/>
+          <p:nvPr/>
+        </p:nvSpPr>
+        <p:spPr>
+          <a:xfrm>
+            <a:off x="347472" y="329184"/>
+            <a:ext cx="11484864" cy="6190488"/>
           </a:xfrm>
           <a:prstGeom prst="rect">
             <a:avLst/>
           </a:prstGeom>
           <a:noFill/>
-        </p:spPr>
-        <p:txBody>
-          <a:bodyPr wrap="none">
-            <a:spAutoFit/>
-          </a:bodyPr>
-          <a:lstStyle/>
-          <a:p>
-            <a:pPr algn="ctr">
-              <a:spcAft>
-                <a:spcPts val="800"/>
-              </a:spcAft>
-            </a:pPr>
-            <a:r>
-              <a:rPr sz="1600" b="1">
-                <a:solidFill>
-                  <a:srgbClr val="FFFFFF"/>
-                </a:solidFill>
-                <a:latin typeface="Microsoft YaHei"/>
-              </a:rPr>
-              <a:t>1</a:t>
-            </a:r>
-          </a:p>
-        </p:txBody>
-      </p:sp>
-      <p:sp>
-        <p:nvSpPr>
-          <p:cNvPr id="10" name="TextBox 9"/>
-          <p:cNvSpPr txBox="1"/>
-          <p:nvPr/>
-        </p:nvSpPr>
-        <p:spPr>
-          <a:xfrm>
-            <a:off x="2148840" y="5010912"/>
-            <a:ext cx="4572000" cy="457200"/>
-          </a:xfrm>
-          <a:prstGeom prst="rect">
-            <a:avLst/>
-          </a:prstGeom>
-          <a:noFill/>
-        </p:spPr>
-        <p:txBody>
-          <a:bodyPr wrap="none">
-            <a:spAutoFit/>
-          </a:bodyPr>
-          <a:lstStyle/>
-          <a:p>
-            <a:pPr algn="l">
-              <a:spcAft>
-                <a:spcPts val="800"/>
-              </a:spcAft>
-            </a:pPr>
-            <a:r>
-              <a:rPr sz="2200" b="1">
-                <a:solidFill>
-                  <a:srgbClr val="321E46"/>
-                </a:solidFill>
-                <a:latin typeface="Microsoft YaHei"/>
-              </a:rPr>
-              <a:t>《小圣施威降大圣》</a:t>
-            </a:r>
-          </a:p>
-        </p:txBody>
-      </p:sp>
-      <p:sp>
-        <p:nvSpPr>
-          <p:cNvPr id="11" name="Oval 10"/>
-          <p:cNvSpPr/>
-          <p:nvPr/>
-        </p:nvSpPr>
-        <p:spPr>
-          <a:xfrm>
-            <a:off x="6400800" y="5029200"/>
-            <a:ext cx="411480" cy="411480"/>
-          </a:xfrm>
-          <a:prstGeom prst="ellipse">
-            <a:avLst/>
-          </a:prstGeom>
-          <a:solidFill>
-            <a:srgbClr val="E66496"/>
-          </a:solidFill>
-          <a:ln>
-            <a:noFill/>
+          <a:ln w="12700">
+            <a:solidFill>
+              <a:srgbClr val="64C8DC"/>
+            </a:solidFill>
           </a:ln>
         </p:spPr>
         <p:style>
@@ -3482,14 +3296,14 @@
       </p:sp>
       <p:sp>
         <p:nvSpPr>
-          <p:cNvPr id="12" name="TextBox 11"/>
+          <p:cNvPr id="8" name="TextBox 7"/>
           <p:cNvSpPr txBox="1"/>
           <p:nvPr/>
         </p:nvSpPr>
         <p:spPr>
           <a:xfrm>
-            <a:off x="6400800" y="5056632"/>
-            <a:ext cx="411480" cy="384048"/>
+            <a:off x="1371600" y="1828800"/>
+            <a:ext cx="9418320" cy="1828800"/>
           </a:xfrm>
           <a:prstGeom prst="rect">
             <a:avLst/>
@@ -3504,76 +3318,53 @@
           <a:p>
             <a:pPr algn="ctr">
               <a:spcAft>
-                <a:spcPts val="800"/>
+                <a:spcPts val="1000"/>
               </a:spcAft>
             </a:pPr>
             <a:r>
-              <a:rPr sz="1600" b="1">
+              <a:rPr sz="5200" b="1">
                 <a:solidFill>
-                  <a:srgbClr val="FFFFFF"/>
+                  <a:srgbClr val="E65096"/>
                 </a:solidFill>
                 <a:latin typeface="Microsoft YaHei"/>
               </a:rPr>
-              <a:t>2</a:t>
-            </a:r>
-          </a:p>
-        </p:txBody>
-      </p:sp>
-      <p:sp>
-        <p:nvSpPr>
-          <p:cNvPr id="13" name="TextBox 12"/>
-          <p:cNvSpPr txBox="1"/>
-          <p:nvPr/>
-        </p:nvSpPr>
-        <p:spPr>
-          <a:xfrm>
-            <a:off x="6903720" y="5010912"/>
-            <a:ext cx="4572000" cy="457200"/>
-          </a:xfrm>
-          <a:prstGeom prst="rect">
-            <a:avLst/>
-          </a:prstGeom>
-          <a:noFill/>
-        </p:spPr>
-        <p:txBody>
-          <a:bodyPr wrap="none">
-            <a:spAutoFit/>
-          </a:bodyPr>
-          <a:lstStyle/>
-          <a:p>
-            <a:pPr algn="l">
+              <a:t>想象力博物馆</a:t>
+            </a:r>
+          </a:p>
+          <a:p>
+            <a:pPr algn="ctr">
               <a:spcAft>
-                <a:spcPts val="800"/>
+                <a:spcPts val="1000"/>
               </a:spcAft>
             </a:pPr>
             <a:r>
-              <a:rPr sz="2200" b="1">
+              <a:rPr sz="2600" b="0">
                 <a:solidFill>
-                  <a:srgbClr val="321E46"/>
+                  <a:srgbClr val="46325A"/>
                 </a:solidFill>
                 <a:latin typeface="Microsoft YaHei"/>
               </a:rPr>
-              <a:t>《皇帝的新装》</a:t>
-            </a:r>
-          </a:p>
-        </p:txBody>
-      </p:sp>
-      <p:sp>
-        <p:nvSpPr>
-          <p:cNvPr id="14" name="Oval 13"/>
+              <a:t>第六单元学历案 · 成果展示</a:t>
+            </a:r>
+          </a:p>
+        </p:txBody>
+      </p:sp>
+      <p:sp>
+        <p:nvSpPr>
+          <p:cNvPr id="9" name="Rectangle 8"/>
           <p:cNvSpPr/>
           <p:nvPr/>
         </p:nvSpPr>
         <p:spPr>
           <a:xfrm>
-            <a:off x="1645920" y="5760720"/>
-            <a:ext cx="411480" cy="411480"/>
-          </a:xfrm>
-          <a:prstGeom prst="ellipse">
+            <a:off x="3200400" y="5029200"/>
+            <a:ext cx="5760720" cy="27432"/>
+          </a:xfrm>
+          <a:prstGeom prst="rect">
             <a:avLst/>
           </a:prstGeom>
           <a:solidFill>
-            <a:srgbClr val="E66496"/>
+            <a:srgbClr val="64C8DC"/>
           </a:solidFill>
           <a:ln>
             <a:noFill/>
@@ -3598,205 +3389,6 @@
           <a:lstStyle/>
           <a:p>
             <a:pPr algn="ctr"/>
-          </a:p>
-        </p:txBody>
-      </p:sp>
-      <p:sp>
-        <p:nvSpPr>
-          <p:cNvPr id="15" name="TextBox 14"/>
-          <p:cNvSpPr txBox="1"/>
-          <p:nvPr/>
-        </p:nvSpPr>
-        <p:spPr>
-          <a:xfrm>
-            <a:off x="1645920" y="5788152"/>
-            <a:ext cx="411480" cy="384048"/>
-          </a:xfrm>
-          <a:prstGeom prst="rect">
-            <a:avLst/>
-          </a:prstGeom>
-          <a:noFill/>
-        </p:spPr>
-        <p:txBody>
-          <a:bodyPr wrap="none">
-            <a:spAutoFit/>
-          </a:bodyPr>
-          <a:lstStyle/>
-          <a:p>
-            <a:pPr algn="ctr">
-              <a:spcAft>
-                <a:spcPts val="800"/>
-              </a:spcAft>
-            </a:pPr>
-            <a:r>
-              <a:rPr sz="1600" b="1">
-                <a:solidFill>
-                  <a:srgbClr val="FFFFFF"/>
-                </a:solidFill>
-                <a:latin typeface="Microsoft YaHei"/>
-              </a:rPr>
-              <a:t>3</a:t>
-            </a:r>
-          </a:p>
-        </p:txBody>
-      </p:sp>
-      <p:sp>
-        <p:nvSpPr>
-          <p:cNvPr id="16" name="TextBox 15"/>
-          <p:cNvSpPr txBox="1"/>
-          <p:nvPr/>
-        </p:nvSpPr>
-        <p:spPr>
-          <a:xfrm>
-            <a:off x="2148840" y="5742432"/>
-            <a:ext cx="4572000" cy="457200"/>
-          </a:xfrm>
-          <a:prstGeom prst="rect">
-            <a:avLst/>
-          </a:prstGeom>
-          <a:noFill/>
-        </p:spPr>
-        <p:txBody>
-          <a:bodyPr wrap="none">
-            <a:spAutoFit/>
-          </a:bodyPr>
-          <a:lstStyle/>
-          <a:p>
-            <a:pPr algn="l">
-              <a:spcAft>
-                <a:spcPts val="800"/>
-              </a:spcAft>
-            </a:pPr>
-            <a:r>
-              <a:rPr sz="2200" b="1">
-                <a:solidFill>
-                  <a:srgbClr val="321E46"/>
-                </a:solidFill>
-                <a:latin typeface="Microsoft YaHei"/>
-              </a:rPr>
-              <a:t>《女娲造人》</a:t>
-            </a:r>
-          </a:p>
-        </p:txBody>
-      </p:sp>
-      <p:sp>
-        <p:nvSpPr>
-          <p:cNvPr id="17" name="Oval 16"/>
-          <p:cNvSpPr/>
-          <p:nvPr/>
-        </p:nvSpPr>
-        <p:spPr>
-          <a:xfrm>
-            <a:off x="6400800" y="5760720"/>
-            <a:ext cx="411480" cy="411480"/>
-          </a:xfrm>
-          <a:prstGeom prst="ellipse">
-            <a:avLst/>
-          </a:prstGeom>
-          <a:solidFill>
-            <a:srgbClr val="E66496"/>
-          </a:solidFill>
-          <a:ln>
-            <a:noFill/>
-          </a:ln>
-        </p:spPr>
-        <p:style>
-          <a:lnRef idx="1">
-            <a:schemeClr val="accent1"/>
-          </a:lnRef>
-          <a:fillRef idx="3">
-            <a:schemeClr val="accent1"/>
-          </a:fillRef>
-          <a:effectRef idx="2">
-            <a:schemeClr val="accent1"/>
-          </a:effectRef>
-          <a:fontRef idx="minor">
-            <a:schemeClr val="lt1"/>
-          </a:fontRef>
-        </p:style>
-        <p:txBody>
-          <a:bodyPr rtlCol="0" anchor="ctr"/>
-          <a:lstStyle/>
-          <a:p>
-            <a:pPr algn="ctr"/>
-          </a:p>
-        </p:txBody>
-      </p:sp>
-      <p:sp>
-        <p:nvSpPr>
-          <p:cNvPr id="18" name="TextBox 17"/>
-          <p:cNvSpPr txBox="1"/>
-          <p:nvPr/>
-        </p:nvSpPr>
-        <p:spPr>
-          <a:xfrm>
-            <a:off x="6400800" y="5788152"/>
-            <a:ext cx="411480" cy="384048"/>
-          </a:xfrm>
-          <a:prstGeom prst="rect">
-            <a:avLst/>
-          </a:prstGeom>
-          <a:noFill/>
-        </p:spPr>
-        <p:txBody>
-          <a:bodyPr wrap="none">
-            <a:spAutoFit/>
-          </a:bodyPr>
-          <a:lstStyle/>
-          <a:p>
-            <a:pPr algn="ctr">
-              <a:spcAft>
-                <a:spcPts val="800"/>
-              </a:spcAft>
-            </a:pPr>
-            <a:r>
-              <a:rPr sz="1600" b="1">
-                <a:solidFill>
-                  <a:srgbClr val="FFFFFF"/>
-                </a:solidFill>
-                <a:latin typeface="Microsoft YaHei"/>
-              </a:rPr>
-              <a:t>4</a:t>
-            </a:r>
-          </a:p>
-        </p:txBody>
-      </p:sp>
-      <p:sp>
-        <p:nvSpPr>
-          <p:cNvPr id="19" name="TextBox 18"/>
-          <p:cNvSpPr txBox="1"/>
-          <p:nvPr/>
-        </p:nvSpPr>
-        <p:spPr>
-          <a:xfrm>
-            <a:off x="6903720" y="5742432"/>
-            <a:ext cx="4572000" cy="457200"/>
-          </a:xfrm>
-          <a:prstGeom prst="rect">
-            <a:avLst/>
-          </a:prstGeom>
-          <a:noFill/>
-        </p:spPr>
-        <p:txBody>
-          <a:bodyPr wrap="none">
-            <a:spAutoFit/>
-          </a:bodyPr>
-          <a:lstStyle/>
-          <a:p>
-            <a:pPr algn="l">
-              <a:spcAft>
-                <a:spcPts val="800"/>
-              </a:spcAft>
-            </a:pPr>
-            <a:r>
-              <a:rPr sz="2200" b="1">
-                <a:solidFill>
-                  <a:srgbClr val="321E46"/>
-                </a:solidFill>
-                <a:latin typeface="Microsoft YaHei"/>
-              </a:rPr>
-              <a:t>《寓言四则》</a:t>
-            </a:r>
           </a:p>
         </p:txBody>
       </p:sp>
@@ -3820,7 +3412,7 @@
       <p:grpSpPr/>
       <p:pic>
         <p:nvPicPr>
-          <p:cNvPr id="2" name="Picture 1" descr="bg_show.png"/>
+          <p:cNvPr id="2" name="Picture 1" descr="bg_final.png"/>
           <p:cNvPicPr>
             <a:picLocks noChangeAspect="1"/>
           </p:cNvPicPr>
@@ -3857,9 +3449,9 @@
             <a:avLst/>
           </a:prstGeom>
           <a:noFill/>
-          <a:ln w="25400">
+          <a:ln w="31750">
             <a:solidFill>
-              <a:srgbClr val="784696"/>
+              <a:srgbClr val="B464B4"/>
             </a:solidFill>
           </a:ln>
         </p:spPr>
@@ -3885,61 +3477,70 @@
           </a:p>
         </p:txBody>
       </p:sp>
-      <p:sp>
-        <p:nvSpPr>
-          <p:cNvPr id="4" name="TextBox 3"/>
-          <p:cNvSpPr txBox="1"/>
-          <p:nvPr/>
-        </p:nvSpPr>
-        <p:spPr>
-          <a:xfrm>
-            <a:off x="2743200" y="548640"/>
-            <a:ext cx="6675120" cy="731520"/>
-          </a:xfrm>
-          <a:prstGeom prst="rect">
-            <a:avLst/>
-          </a:prstGeom>
-          <a:noFill/>
-        </p:spPr>
-        <p:txBody>
-          <a:bodyPr wrap="none">
-            <a:spAutoFit/>
-          </a:bodyPr>
-          <a:lstStyle/>
-          <a:p>
-            <a:pPr algn="ctr">
-              <a:spcAft>
-                <a:spcPts val="800"/>
-              </a:spcAft>
-            </a:pPr>
-            <a:r>
-              <a:rPr sz="3800" b="1">
-                <a:solidFill>
-                  <a:srgbClr val="784696"/>
-                </a:solidFill>
-                <a:latin typeface="Microsoft YaHei"/>
-              </a:rPr>
-              <a:t>单元母题链</a:t>
-            </a:r>
-          </a:p>
-        </p:txBody>
-      </p:sp>
-      <p:sp>
-        <p:nvSpPr>
-          <p:cNvPr id="5" name="Oval 4"/>
+      <p:pic>
+        <p:nvPicPr>
+          <p:cNvPr id="4" name="Picture 3" descr="corner_final_tl.png"/>
+          <p:cNvPicPr>
+            <a:picLocks noChangeAspect="1"/>
+          </p:cNvPicPr>
+          <p:nvPr/>
+        </p:nvPicPr>
+        <p:blipFill>
+          <a:blip r:embed="rId3"/>
+          <a:stretch>
+            <a:fillRect/>
+          </a:stretch>
+        </p:blipFill>
+        <p:spPr>
+          <a:xfrm>
+            <a:off x="-45720" y="-45720"/>
+            <a:ext cx="2011680" cy="2011680"/>
+          </a:xfrm>
+          <a:prstGeom prst="rect">
+            <a:avLst/>
+          </a:prstGeom>
+        </p:spPr>
+      </p:pic>
+      <p:pic>
+        <p:nvPicPr>
+          <p:cNvPr id="5" name="Picture 4" descr="corner_final_tr.png"/>
+          <p:cNvPicPr>
+            <a:picLocks noChangeAspect="1"/>
+          </p:cNvPicPr>
+          <p:nvPr/>
+        </p:nvPicPr>
+        <p:blipFill>
+          <a:blip r:embed="rId4"/>
+          <a:stretch>
+            <a:fillRect/>
+          </a:stretch>
+        </p:blipFill>
+        <p:spPr>
+          <a:xfrm>
+            <a:off x="9875520" y="-45720"/>
+            <a:ext cx="2011680" cy="2011680"/>
+          </a:xfrm>
+          <a:prstGeom prst="rect">
+            <a:avLst/>
+          </a:prstGeom>
+        </p:spPr>
+      </p:pic>
+      <p:sp>
+        <p:nvSpPr>
+          <p:cNvPr id="6" name="Rounded Rectangle 5"/>
           <p:cNvSpPr/>
           <p:nvPr/>
         </p:nvSpPr>
         <p:spPr>
           <a:xfrm>
-            <a:off x="1371600" y="1463040"/>
-            <a:ext cx="384048" cy="384048"/>
-          </a:xfrm>
-          <a:prstGeom prst="ellipse">
+            <a:off x="4953304" y="502920"/>
+            <a:ext cx="2286000" cy="411480"/>
+          </a:xfrm>
+          <a:prstGeom prst="roundRect">
             <a:avLst/>
           </a:prstGeom>
           <a:solidFill>
-            <a:srgbClr val="E66496"/>
+            <a:srgbClr val="64C8DC"/>
           </a:solidFill>
           <a:ln>
             <a:noFill/>
@@ -3969,14 +3570,14 @@
       </p:sp>
       <p:sp>
         <p:nvSpPr>
-          <p:cNvPr id="6" name="TextBox 5"/>
+          <p:cNvPr id="7" name="TextBox 6"/>
           <p:cNvSpPr txBox="1"/>
           <p:nvPr/>
         </p:nvSpPr>
         <p:spPr>
           <a:xfrm>
-            <a:off x="1371600" y="1481328"/>
-            <a:ext cx="384048" cy="347472"/>
+            <a:off x="4953304" y="521208"/>
+            <a:ext cx="2286000" cy="384048"/>
           </a:xfrm>
           <a:prstGeom prst="rect">
             <a:avLst/>
@@ -3991,31 +3592,31 @@
           <a:p>
             <a:pPr algn="ctr">
               <a:spcAft>
-                <a:spcPts val="800"/>
+                <a:spcPts val="1000"/>
               </a:spcAft>
             </a:pPr>
             <a:r>
-              <a:rPr sz="1400" b="1">
+              <a:rPr sz="1800" b="1">
                 <a:solidFill>
-                  <a:srgbClr val="FFFFFF"/>
+                  <a:srgbClr val="46325A"/>
                 </a:solidFill>
                 <a:latin typeface="Microsoft YaHei"/>
               </a:rPr>
-              <a:t>1</a:t>
-            </a:r>
-          </a:p>
-        </p:txBody>
-      </p:sp>
-      <p:sp>
-        <p:nvSpPr>
-          <p:cNvPr id="7" name="TextBox 6"/>
+              <a:t>比较笔记</a:t>
+            </a:r>
+          </a:p>
+        </p:txBody>
+      </p:sp>
+      <p:sp>
+        <p:nvSpPr>
+          <p:cNvPr id="8" name="TextBox 7"/>
           <p:cNvSpPr txBox="1"/>
           <p:nvPr/>
         </p:nvSpPr>
         <p:spPr>
           <a:xfrm>
-            <a:off x="1920240" y="1444752"/>
-            <a:ext cx="9144000" cy="594360"/>
+            <a:off x="1371600" y="1051560"/>
+            <a:ext cx="9418320" cy="822960"/>
           </a:xfrm>
           <a:prstGeom prst="rect">
             <a:avLst/>
@@ -4023,53 +3624,44 @@
           <a:noFill/>
         </p:spPr>
         <p:txBody>
-          <a:bodyPr wrap="none">
+          <a:bodyPr wrap="square">
             <a:spAutoFit/>
           </a:bodyPr>
           <a:lstStyle/>
           <a:p>
-            <a:pPr algn="l">
+            <a:pPr algn="ctr">
               <a:spcAft>
-                <a:spcPts val="800"/>
+                <a:spcPts val="1000"/>
               </a:spcAft>
             </a:pPr>
             <a:r>
-              <a:rPr sz="2400" b="1">
+              <a:rPr sz="3600" b="1">
                 <a:solidFill>
-                  <a:srgbClr val="784696"/>
+                  <a:srgbClr val="E65096"/>
                 </a:solidFill>
                 <a:latin typeface="Microsoft YaHei"/>
               </a:rPr>
-              <a:t>单元母题：</a:t>
-            </a:r>
-            <a:r>
-              <a:rPr sz="2400" b="0">
-                <a:solidFill>
-                  <a:srgbClr val="321E46"/>
-                </a:solidFill>
-                <a:latin typeface="Microsoft YaHei"/>
-              </a:rPr>
-              <a:t>想象与真实</a:t>
-            </a:r>
-          </a:p>
-        </p:txBody>
-      </p:sp>
-      <p:sp>
-        <p:nvSpPr>
-          <p:cNvPr id="8" name="Oval 7"/>
+              <a:t>四类文本比较</a:t>
+            </a:r>
+          </a:p>
+        </p:txBody>
+      </p:sp>
+      <p:sp>
+        <p:nvSpPr>
+          <p:cNvPr id="9" name="Rectangle 8"/>
           <p:cNvSpPr/>
           <p:nvPr/>
         </p:nvSpPr>
         <p:spPr>
           <a:xfrm>
-            <a:off x="1371600" y="2148840"/>
-            <a:ext cx="384048" cy="384048"/>
-          </a:xfrm>
-          <a:prstGeom prst="ellipse">
+            <a:off x="3200400" y="1691640"/>
+            <a:ext cx="5760720" cy="27432"/>
+          </a:xfrm>
+          <a:prstGeom prst="rect">
             <a:avLst/>
           </a:prstGeom>
           <a:solidFill>
-            <a:srgbClr val="E66496"/>
+            <a:srgbClr val="64C8DC"/>
           </a:solidFill>
           <a:ln>
             <a:noFill/>
@@ -4099,110 +3691,25 @@
       </p:sp>
       <p:sp>
         <p:nvSpPr>
-          <p:cNvPr id="9" name="TextBox 8"/>
-          <p:cNvSpPr txBox="1"/>
-          <p:nvPr/>
-        </p:nvSpPr>
-        <p:spPr>
-          <a:xfrm>
-            <a:off x="1371600" y="2167128"/>
-            <a:ext cx="384048" cy="347472"/>
-          </a:xfrm>
-          <a:prstGeom prst="rect">
-            <a:avLst/>
-          </a:prstGeom>
-          <a:noFill/>
-        </p:spPr>
-        <p:txBody>
-          <a:bodyPr wrap="none">
-            <a:spAutoFit/>
-          </a:bodyPr>
-          <a:lstStyle/>
-          <a:p>
-            <a:pPr algn="ctr">
-              <a:spcAft>
-                <a:spcPts val="800"/>
-              </a:spcAft>
-            </a:pPr>
-            <a:r>
-              <a:rPr sz="1400" b="1">
-                <a:solidFill>
-                  <a:srgbClr val="FFFFFF"/>
-                </a:solidFill>
-                <a:latin typeface="Microsoft YaHei"/>
-              </a:rPr>
-              <a:t>2</a:t>
-            </a:r>
-          </a:p>
-        </p:txBody>
-      </p:sp>
-      <p:sp>
-        <p:nvSpPr>
-          <p:cNvPr id="10" name="TextBox 9"/>
-          <p:cNvSpPr txBox="1"/>
-          <p:nvPr/>
-        </p:nvSpPr>
-        <p:spPr>
-          <a:xfrm>
-            <a:off x="1920240" y="2130552"/>
-            <a:ext cx="9144000" cy="594360"/>
-          </a:xfrm>
-          <a:prstGeom prst="rect">
-            <a:avLst/>
-          </a:prstGeom>
-          <a:noFill/>
-        </p:spPr>
-        <p:txBody>
-          <a:bodyPr wrap="none">
-            <a:spAutoFit/>
-          </a:bodyPr>
-          <a:lstStyle/>
-          <a:p>
-            <a:pPr algn="l">
-              <a:spcAft>
-                <a:spcPts val="800"/>
-              </a:spcAft>
-            </a:pPr>
-            <a:r>
-              <a:rPr sz="2400" b="1">
-                <a:solidFill>
-                  <a:srgbClr val="784696"/>
-                </a:solidFill>
-                <a:latin typeface="Microsoft YaHei"/>
-              </a:rPr>
-              <a:t>自由与规则：</a:t>
-            </a:r>
-            <a:r>
-              <a:rPr sz="2400" b="0">
-                <a:solidFill>
-                  <a:srgbClr val="321E46"/>
-                </a:solidFill>
-                <a:latin typeface="Microsoft YaHei"/>
-              </a:rPr>
-              <a:t>《小圣施威降大圣》</a:t>
-            </a:r>
-          </a:p>
-        </p:txBody>
-      </p:sp>
-      <p:sp>
-        <p:nvSpPr>
-          <p:cNvPr id="11" name="Oval 10"/>
+          <p:cNvPr id="10" name="Rounded Rectangle 9"/>
           <p:cNvSpPr/>
           <p:nvPr/>
         </p:nvSpPr>
         <p:spPr>
           <a:xfrm>
-            <a:off x="1371600" y="2834640"/>
-            <a:ext cx="384048" cy="384048"/>
-          </a:xfrm>
-          <a:prstGeom prst="ellipse">
+            <a:off x="1249984" y="1810512"/>
+            <a:ext cx="9692640" cy="3319272"/>
+          </a:xfrm>
+          <a:prstGeom prst="roundRect">
             <a:avLst/>
           </a:prstGeom>
           <a:solidFill>
-            <a:srgbClr val="E66496"/>
+            <a:srgbClr val="FFFAFF"/>
           </a:solidFill>
-          <a:ln>
-            <a:noFill/>
+          <a:ln w="19050">
+            <a:solidFill>
+              <a:srgbClr val="64C8DC"/>
+            </a:solidFill>
           </a:ln>
         </p:spPr>
         <p:style>
@@ -4229,14 +3736,14 @@
       </p:sp>
       <p:sp>
         <p:nvSpPr>
-          <p:cNvPr id="12" name="TextBox 11"/>
+          <p:cNvPr id="11" name="TextBox 10"/>
           <p:cNvSpPr txBox="1"/>
           <p:nvPr/>
         </p:nvSpPr>
         <p:spPr>
           <a:xfrm>
-            <a:off x="1371600" y="2852928"/>
-            <a:ext cx="384048" cy="347472"/>
+            <a:off x="1463040" y="1920240"/>
+            <a:ext cx="2103120" cy="502920"/>
           </a:xfrm>
           <a:prstGeom prst="rect">
             <a:avLst/>
@@ -4249,33 +3756,33 @@
           </a:bodyPr>
           <a:lstStyle/>
           <a:p>
-            <a:pPr algn="ctr">
+            <a:pPr algn="r">
               <a:spcAft>
-                <a:spcPts val="800"/>
+                <a:spcPts val="1000"/>
               </a:spcAft>
             </a:pPr>
             <a:r>
-              <a:rPr sz="1400" b="1">
+              <a:rPr sz="2200" b="1">
                 <a:solidFill>
-                  <a:srgbClr val="FFFFFF"/>
+                  <a:srgbClr val="E65096"/>
                 </a:solidFill>
                 <a:latin typeface="Microsoft YaHei"/>
               </a:rPr>
-              <a:t>3</a:t>
-            </a:r>
-          </a:p>
-        </p:txBody>
-      </p:sp>
-      <p:sp>
-        <p:nvSpPr>
-          <p:cNvPr id="13" name="TextBox 12"/>
+              <a:t>神魔小说</a:t>
+            </a:r>
+          </a:p>
+        </p:txBody>
+      </p:sp>
+      <p:sp>
+        <p:nvSpPr>
+          <p:cNvPr id="12" name="TextBox 11"/>
           <p:cNvSpPr txBox="1"/>
           <p:nvPr/>
         </p:nvSpPr>
         <p:spPr>
           <a:xfrm>
-            <a:off x="1920240" y="2816352"/>
-            <a:ext cx="9144000" cy="594360"/>
+            <a:off x="3749039" y="1920240"/>
+            <a:ext cx="7132320" cy="685800"/>
           </a:xfrm>
           <a:prstGeom prst="rect">
             <a:avLst/>
@@ -4290,83 +3797,70 @@
           <a:p>
             <a:pPr algn="l">
               <a:spcAft>
-                <a:spcPts val="800"/>
+                <a:spcPts val="1000"/>
               </a:spcAft>
             </a:pPr>
             <a:r>
-              <a:rPr sz="2400" b="1">
+              <a:rPr sz="2200" b="0">
                 <a:solidFill>
-                  <a:srgbClr val="784696"/>
+                  <a:srgbClr val="46325A"/>
                 </a:solidFill>
                 <a:latin typeface="Microsoft YaHei"/>
               </a:rPr>
-              <a:t>真实与虚假：</a:t>
-            </a:r>
-            <a:r>
-              <a:rPr sz="2400" b="0">
+              <a:t>想象依据：相克逻辑；表现：连续变化；意味：人情世故</a:t>
+            </a:r>
+          </a:p>
+        </p:txBody>
+      </p:sp>
+      <p:sp>
+        <p:nvSpPr>
+          <p:cNvPr id="13" name="TextBox 12"/>
+          <p:cNvSpPr txBox="1"/>
+          <p:nvPr/>
+        </p:nvSpPr>
+        <p:spPr>
+          <a:xfrm>
+            <a:off x="1463040" y="2670048"/>
+            <a:ext cx="2103120" cy="502920"/>
+          </a:xfrm>
+          <a:prstGeom prst="rect">
+            <a:avLst/>
+          </a:prstGeom>
+          <a:noFill/>
+        </p:spPr>
+        <p:txBody>
+          <a:bodyPr wrap="none">
+            <a:spAutoFit/>
+          </a:bodyPr>
+          <a:lstStyle/>
+          <a:p>
+            <a:pPr algn="r">
+              <a:spcAft>
+                <a:spcPts val="1000"/>
+              </a:spcAft>
+            </a:pPr>
+            <a:r>
+              <a:rPr sz="2200" b="1">
                 <a:solidFill>
-                  <a:srgbClr val="321E46"/>
+                  <a:srgbClr val="E65096"/>
                 </a:solidFill>
                 <a:latin typeface="Microsoft YaHei"/>
               </a:rPr>
-              <a:t>《皇帝的新装》</a:t>
-            </a:r>
-          </a:p>
-        </p:txBody>
-      </p:sp>
-      <p:sp>
-        <p:nvSpPr>
-          <p:cNvPr id="14" name="Oval 13"/>
-          <p:cNvSpPr/>
-          <p:nvPr/>
-        </p:nvSpPr>
-        <p:spPr>
-          <a:xfrm>
-            <a:off x="1371600" y="3520440"/>
-            <a:ext cx="384048" cy="384048"/>
-          </a:xfrm>
-          <a:prstGeom prst="ellipse">
-            <a:avLst/>
-          </a:prstGeom>
-          <a:solidFill>
-            <a:srgbClr val="E66496"/>
-          </a:solidFill>
-          <a:ln>
-            <a:noFill/>
-          </a:ln>
-        </p:spPr>
-        <p:style>
-          <a:lnRef idx="1">
-            <a:schemeClr val="accent1"/>
-          </a:lnRef>
-          <a:fillRef idx="3">
-            <a:schemeClr val="accent1"/>
-          </a:fillRef>
-          <a:effectRef idx="2">
-            <a:schemeClr val="accent1"/>
-          </a:effectRef>
-          <a:fontRef idx="minor">
-            <a:schemeClr val="lt1"/>
-          </a:fontRef>
-        </p:style>
-        <p:txBody>
-          <a:bodyPr rtlCol="0" anchor="ctr"/>
-          <a:lstStyle/>
-          <a:p>
-            <a:pPr algn="ctr"/>
-          </a:p>
-        </p:txBody>
-      </p:sp>
-      <p:sp>
-        <p:nvSpPr>
-          <p:cNvPr id="15" name="TextBox 14"/>
+              <a:t>童话</a:t>
+            </a:r>
+          </a:p>
+        </p:txBody>
+      </p:sp>
+      <p:sp>
+        <p:nvSpPr>
+          <p:cNvPr id="14" name="TextBox 13"/>
           <p:cNvSpPr txBox="1"/>
           <p:nvPr/>
         </p:nvSpPr>
         <p:spPr>
           <a:xfrm>
-            <a:off x="1371600" y="3538728"/>
-            <a:ext cx="384048" cy="347472"/>
+            <a:off x="3749039" y="2670048"/>
+            <a:ext cx="7132320" cy="685800"/>
           </a:xfrm>
           <a:prstGeom prst="rect">
             <a:avLst/>
@@ -4379,33 +3873,33 @@
           </a:bodyPr>
           <a:lstStyle/>
           <a:p>
-            <a:pPr algn="ctr">
+            <a:pPr algn="l">
               <a:spcAft>
-                <a:spcPts val="800"/>
+                <a:spcPts val="1000"/>
               </a:spcAft>
             </a:pPr>
             <a:r>
-              <a:rPr sz="1400" b="1">
+              <a:rPr sz="2200" b="0">
                 <a:solidFill>
-                  <a:srgbClr val="FFFFFF"/>
+                  <a:srgbClr val="46325A"/>
                 </a:solidFill>
                 <a:latin typeface="Microsoft YaHei"/>
               </a:rPr>
-              <a:t>4</a:t>
-            </a:r>
-          </a:p>
-        </p:txBody>
-      </p:sp>
-      <p:sp>
-        <p:nvSpPr>
-          <p:cNvPr id="16" name="TextBox 15"/>
+              <a:t>想象依据：生活经验；表现：夸张反讽；意味：照见人性</a:t>
+            </a:r>
+          </a:p>
+        </p:txBody>
+      </p:sp>
+      <p:sp>
+        <p:nvSpPr>
+          <p:cNvPr id="15" name="TextBox 14"/>
           <p:cNvSpPr txBox="1"/>
           <p:nvPr/>
         </p:nvSpPr>
         <p:spPr>
           <a:xfrm>
-            <a:off x="1920240" y="3502152"/>
-            <a:ext cx="9144000" cy="594360"/>
+            <a:off x="1463040" y="3419856"/>
+            <a:ext cx="2103120" cy="502920"/>
           </a:xfrm>
           <a:prstGeom prst="rect">
             <a:avLst/>
@@ -4418,85 +3912,72 @@
           </a:bodyPr>
           <a:lstStyle/>
           <a:p>
-            <a:pPr algn="l">
+            <a:pPr algn="r">
               <a:spcAft>
-                <a:spcPts val="800"/>
+                <a:spcPts val="1000"/>
               </a:spcAft>
             </a:pPr>
             <a:r>
-              <a:rPr sz="2400" b="1">
+              <a:rPr sz="2200" b="1">
                 <a:solidFill>
-                  <a:srgbClr val="784696"/>
+                  <a:srgbClr val="E65096"/>
                 </a:solidFill>
                 <a:latin typeface="Microsoft YaHei"/>
               </a:rPr>
-              <a:t>创造与生命：</a:t>
-            </a:r>
-            <a:r>
-              <a:rPr sz="2400" b="0">
+              <a:t>神话</a:t>
+            </a:r>
+          </a:p>
+        </p:txBody>
+      </p:sp>
+      <p:sp>
+        <p:nvSpPr>
+          <p:cNvPr id="16" name="TextBox 15"/>
+          <p:cNvSpPr txBox="1"/>
+          <p:nvPr/>
+        </p:nvSpPr>
+        <p:spPr>
+          <a:xfrm>
+            <a:off x="3749039" y="3419856"/>
+            <a:ext cx="7132320" cy="685800"/>
+          </a:xfrm>
+          <a:prstGeom prst="rect">
+            <a:avLst/>
+          </a:prstGeom>
+          <a:noFill/>
+        </p:spPr>
+        <p:txBody>
+          <a:bodyPr wrap="none">
+            <a:spAutoFit/>
+          </a:bodyPr>
+          <a:lstStyle/>
+          <a:p>
+            <a:pPr algn="l">
+              <a:spcAft>
+                <a:spcPts val="1000"/>
+              </a:spcAft>
+            </a:pPr>
+            <a:r>
+              <a:rPr sz="2200" b="0">
                 <a:solidFill>
-                  <a:srgbClr val="321E46"/>
+                  <a:srgbClr val="46325A"/>
                 </a:solidFill>
                 <a:latin typeface="Microsoft YaHei"/>
               </a:rPr>
-              <a:t>《女娲造人》</a:t>
-            </a:r>
-          </a:p>
-        </p:txBody>
-      </p:sp>
-      <p:sp>
-        <p:nvSpPr>
-          <p:cNvPr id="17" name="Oval 16"/>
-          <p:cNvSpPr/>
-          <p:nvPr/>
-        </p:nvSpPr>
-        <p:spPr>
-          <a:xfrm>
-            <a:off x="1371600" y="4206240"/>
-            <a:ext cx="384048" cy="384048"/>
-          </a:xfrm>
-          <a:prstGeom prst="ellipse">
-            <a:avLst/>
-          </a:prstGeom>
-          <a:solidFill>
-            <a:srgbClr val="E66496"/>
-          </a:solidFill>
-          <a:ln>
-            <a:noFill/>
-          </a:ln>
-        </p:spPr>
-        <p:style>
-          <a:lnRef idx="1">
-            <a:schemeClr val="accent1"/>
-          </a:lnRef>
-          <a:fillRef idx="3">
-            <a:schemeClr val="accent1"/>
-          </a:fillRef>
-          <a:effectRef idx="2">
-            <a:schemeClr val="accent1"/>
-          </a:effectRef>
-          <a:fontRef idx="minor">
-            <a:schemeClr val="lt1"/>
-          </a:fontRef>
-        </p:style>
-        <p:txBody>
-          <a:bodyPr rtlCol="0" anchor="ctr"/>
-          <a:lstStyle/>
-          <a:p>
-            <a:pPr algn="ctr"/>
-          </a:p>
-        </p:txBody>
-      </p:sp>
-      <p:sp>
-        <p:nvSpPr>
-          <p:cNvPr id="18" name="TextBox 17"/>
+              <a:t>想象依据：古籍传说；表现：创世画面；意味：礼赞生命</a:t>
+            </a:r>
+          </a:p>
+        </p:txBody>
+      </p:sp>
+      <p:sp>
+        <p:nvSpPr>
+          <p:cNvPr id="17" name="TextBox 16"/>
           <p:cNvSpPr txBox="1"/>
           <p:nvPr/>
         </p:nvSpPr>
         <p:spPr>
           <a:xfrm>
-            <a:off x="1371600" y="4224527"/>
-            <a:ext cx="384048" cy="347472"/>
+            <a:off x="1463040" y="4169664"/>
+            <a:ext cx="2103120" cy="502920"/>
           </a:xfrm>
           <a:prstGeom prst="rect">
             <a:avLst/>
@@ -4509,33 +3990,33 @@
           </a:bodyPr>
           <a:lstStyle/>
           <a:p>
-            <a:pPr algn="ctr">
+            <a:pPr algn="r">
               <a:spcAft>
-                <a:spcPts val="800"/>
+                <a:spcPts val="1000"/>
               </a:spcAft>
             </a:pPr>
             <a:r>
-              <a:rPr sz="1400" b="1">
+              <a:rPr sz="2200" b="1">
                 <a:solidFill>
-                  <a:srgbClr val="FFFFFF"/>
+                  <a:srgbClr val="E65096"/>
                 </a:solidFill>
                 <a:latin typeface="Microsoft YaHei"/>
               </a:rPr>
-              <a:t>5</a:t>
-            </a:r>
-          </a:p>
-        </p:txBody>
-      </p:sp>
-      <p:sp>
-        <p:nvSpPr>
-          <p:cNvPr id="19" name="TextBox 18"/>
+              <a:t>寓言</a:t>
+            </a:r>
+          </a:p>
+        </p:txBody>
+      </p:sp>
+      <p:sp>
+        <p:nvSpPr>
+          <p:cNvPr id="18" name="TextBox 17"/>
           <p:cNvSpPr txBox="1"/>
           <p:nvPr/>
         </p:nvSpPr>
         <p:spPr>
           <a:xfrm>
-            <a:off x="1920240" y="4187952"/>
-            <a:ext cx="9144000" cy="594360"/>
+            <a:off x="3749039" y="4169664"/>
+            <a:ext cx="7132320" cy="685800"/>
           </a:xfrm>
           <a:prstGeom prst="rect">
             <a:avLst/>
@@ -4550,26 +4031,17 @@
           <a:p>
             <a:pPr algn="l">
               <a:spcAft>
-                <a:spcPts val="800"/>
+                <a:spcPts val="1000"/>
               </a:spcAft>
             </a:pPr>
             <a:r>
-              <a:rPr sz="2400" b="1">
+              <a:rPr sz="2200" b="0">
                 <a:solidFill>
-                  <a:srgbClr val="784696"/>
+                  <a:srgbClr val="46325A"/>
                 </a:solidFill>
                 <a:latin typeface="Microsoft YaHei"/>
               </a:rPr>
-              <a:t>智慧与局限：</a:t>
-            </a:r>
-            <a:r>
-              <a:rPr sz="2400" b="0">
-                <a:solidFill>
-                  <a:srgbClr val="321E46"/>
-                </a:solidFill>
-                <a:latin typeface="Microsoft YaHei"/>
-              </a:rPr>
-              <a:t>《寓言四则》</a:t>
+              <a:t>想象依据：生活现象；表现：拟人故事；意味：警醒智慧</a:t>
             </a:r>
           </a:p>
         </p:txBody>
@@ -4594,7 +4066,7 @@
       <p:grpSpPr/>
       <p:pic>
         <p:nvPicPr>
-          <p:cNvPr id="2" name="Picture 1" descr="bg_show.png"/>
+          <p:cNvPr id="2" name="Picture 1" descr="bg_final.png"/>
           <p:cNvPicPr>
             <a:picLocks noChangeAspect="1"/>
           </p:cNvPicPr>
@@ -4631,9 +4103,9 @@
             <a:avLst/>
           </a:prstGeom>
           <a:noFill/>
-          <a:ln w="25400">
+          <a:ln w="31750">
             <a:solidFill>
-              <a:srgbClr val="784696"/>
+              <a:srgbClr val="B464B4"/>
             </a:solidFill>
           </a:ln>
         </p:spPr>
@@ -4659,61 +4131,70 @@
           </a:p>
         </p:txBody>
       </p:sp>
-      <p:sp>
-        <p:nvSpPr>
-          <p:cNvPr id="4" name="TextBox 3"/>
-          <p:cNvSpPr txBox="1"/>
-          <p:nvPr/>
-        </p:nvSpPr>
-        <p:spPr>
-          <a:xfrm>
-            <a:off x="2743200" y="548640"/>
-            <a:ext cx="6675120" cy="731520"/>
-          </a:xfrm>
-          <a:prstGeom prst="rect">
-            <a:avLst/>
-          </a:prstGeom>
-          <a:noFill/>
-        </p:spPr>
-        <p:txBody>
-          <a:bodyPr wrap="none">
-            <a:spAutoFit/>
-          </a:bodyPr>
-          <a:lstStyle/>
-          <a:p>
-            <a:pPr algn="ctr">
-              <a:spcAft>
-                <a:spcPts val="800"/>
-              </a:spcAft>
-            </a:pPr>
-            <a:r>
-              <a:rPr sz="3800" b="1">
-                <a:solidFill>
-                  <a:srgbClr val="784696"/>
-                </a:solidFill>
-                <a:latin typeface="Microsoft YaHei"/>
-              </a:rPr>
-              <a:t>四类文本比较</a:t>
-            </a:r>
-          </a:p>
-        </p:txBody>
-      </p:sp>
-      <p:sp>
-        <p:nvSpPr>
-          <p:cNvPr id="5" name="Oval 4"/>
+      <p:pic>
+        <p:nvPicPr>
+          <p:cNvPr id="4" name="Picture 3" descr="corner_final_tl.png"/>
+          <p:cNvPicPr>
+            <a:picLocks noChangeAspect="1"/>
+          </p:cNvPicPr>
+          <p:nvPr/>
+        </p:nvPicPr>
+        <p:blipFill>
+          <a:blip r:embed="rId3"/>
+          <a:stretch>
+            <a:fillRect/>
+          </a:stretch>
+        </p:blipFill>
+        <p:spPr>
+          <a:xfrm>
+            <a:off x="-45720" y="-45720"/>
+            <a:ext cx="2011680" cy="2011680"/>
+          </a:xfrm>
+          <a:prstGeom prst="rect">
+            <a:avLst/>
+          </a:prstGeom>
+        </p:spPr>
+      </p:pic>
+      <p:pic>
+        <p:nvPicPr>
+          <p:cNvPr id="5" name="Picture 4" descr="corner_final_tr.png"/>
+          <p:cNvPicPr>
+            <a:picLocks noChangeAspect="1"/>
+          </p:cNvPicPr>
+          <p:nvPr/>
+        </p:nvPicPr>
+        <p:blipFill>
+          <a:blip r:embed="rId4"/>
+          <a:stretch>
+            <a:fillRect/>
+          </a:stretch>
+        </p:blipFill>
+        <p:spPr>
+          <a:xfrm>
+            <a:off x="9875520" y="-45720"/>
+            <a:ext cx="2011680" cy="2011680"/>
+          </a:xfrm>
+          <a:prstGeom prst="rect">
+            <a:avLst/>
+          </a:prstGeom>
+        </p:spPr>
+      </p:pic>
+      <p:sp>
+        <p:nvSpPr>
+          <p:cNvPr id="6" name="Rounded Rectangle 5"/>
           <p:cNvSpPr/>
           <p:nvPr/>
         </p:nvSpPr>
         <p:spPr>
           <a:xfrm>
-            <a:off x="1371600" y="1463040"/>
-            <a:ext cx="384048" cy="384048"/>
-          </a:xfrm>
-          <a:prstGeom prst="ellipse">
+            <a:off x="4953304" y="502920"/>
+            <a:ext cx="2286000" cy="411480"/>
+          </a:xfrm>
+          <a:prstGeom prst="roundRect">
             <a:avLst/>
           </a:prstGeom>
           <a:solidFill>
-            <a:srgbClr val="E66496"/>
+            <a:srgbClr val="64C8DC"/>
           </a:solidFill>
           <a:ln>
             <a:noFill/>
@@ -4743,14 +4224,14 @@
       </p:sp>
       <p:sp>
         <p:nvSpPr>
-          <p:cNvPr id="6" name="TextBox 5"/>
+          <p:cNvPr id="7" name="TextBox 6"/>
           <p:cNvSpPr txBox="1"/>
           <p:nvPr/>
         </p:nvSpPr>
         <p:spPr>
           <a:xfrm>
-            <a:off x="1371600" y="1481328"/>
-            <a:ext cx="384048" cy="347472"/>
+            <a:off x="4953304" y="521208"/>
+            <a:ext cx="2286000" cy="384048"/>
           </a:xfrm>
           <a:prstGeom prst="rect">
             <a:avLst/>
@@ -4765,31 +4246,31 @@
           <a:p>
             <a:pPr algn="ctr">
               <a:spcAft>
-                <a:spcPts val="800"/>
+                <a:spcPts val="1000"/>
               </a:spcAft>
             </a:pPr>
             <a:r>
-              <a:rPr sz="1400" b="1">
+              <a:rPr sz="1800" b="1">
                 <a:solidFill>
-                  <a:srgbClr val="FFFFFF"/>
+                  <a:srgbClr val="46325A"/>
                 </a:solidFill>
                 <a:latin typeface="Microsoft YaHei"/>
               </a:rPr>
-              <a:t>1</a:t>
-            </a:r>
-          </a:p>
-        </p:txBody>
-      </p:sp>
-      <p:sp>
-        <p:nvSpPr>
-          <p:cNvPr id="7" name="TextBox 6"/>
+              <a:t>写作笔记</a:t>
+            </a:r>
+          </a:p>
+        </p:txBody>
+      </p:sp>
+      <p:sp>
+        <p:nvSpPr>
+          <p:cNvPr id="8" name="TextBox 7"/>
           <p:cNvSpPr txBox="1"/>
           <p:nvPr/>
         </p:nvSpPr>
         <p:spPr>
           <a:xfrm>
-            <a:off x="1920240" y="1444752"/>
-            <a:ext cx="9144000" cy="594360"/>
+            <a:off x="1371600" y="1051560"/>
+            <a:ext cx="9418320" cy="822960"/>
           </a:xfrm>
           <a:prstGeom prst="rect">
             <a:avLst/>
@@ -4797,53 +4278,44 @@
           <a:noFill/>
         </p:spPr>
         <p:txBody>
-          <a:bodyPr wrap="none">
+          <a:bodyPr wrap="square">
             <a:spAutoFit/>
           </a:bodyPr>
           <a:lstStyle/>
           <a:p>
-            <a:pPr algn="l">
+            <a:pPr algn="ctr">
               <a:spcAft>
-                <a:spcPts val="800"/>
+                <a:spcPts val="1000"/>
               </a:spcAft>
             </a:pPr>
             <a:r>
-              <a:rPr sz="2400" b="1">
+              <a:rPr sz="3600" b="1">
                 <a:solidFill>
-                  <a:srgbClr val="784696"/>
+                  <a:srgbClr val="E65096"/>
                 </a:solidFill>
                 <a:latin typeface="Microsoft YaHei"/>
               </a:rPr>
-              <a:t>神魔小说：</a:t>
-            </a:r>
-            <a:r>
-              <a:rPr sz="2400" b="0">
-                <a:solidFill>
-                  <a:srgbClr val="321E46"/>
-                </a:solidFill>
-                <a:latin typeface="Microsoft YaHei"/>
-              </a:rPr>
-              <a:t>想象依据：相克逻辑；表现：连续变化</a:t>
-            </a:r>
-          </a:p>
-        </p:txBody>
-      </p:sp>
-      <p:sp>
-        <p:nvSpPr>
-          <p:cNvPr id="8" name="Oval 7"/>
+              <a:t>联想与想象</a:t>
+            </a:r>
+          </a:p>
+        </p:txBody>
+      </p:sp>
+      <p:sp>
+        <p:nvSpPr>
+          <p:cNvPr id="9" name="Rectangle 8"/>
           <p:cNvSpPr/>
           <p:nvPr/>
         </p:nvSpPr>
         <p:spPr>
           <a:xfrm>
-            <a:off x="1371600" y="2148840"/>
-            <a:ext cx="384048" cy="384048"/>
-          </a:xfrm>
-          <a:prstGeom prst="ellipse">
+            <a:off x="3200400" y="1691640"/>
+            <a:ext cx="5760720" cy="27432"/>
+          </a:xfrm>
+          <a:prstGeom prst="rect">
             <a:avLst/>
           </a:prstGeom>
           <a:solidFill>
-            <a:srgbClr val="E66496"/>
+            <a:srgbClr val="64C8DC"/>
           </a:solidFill>
           <a:ln>
             <a:noFill/>
@@ -4873,110 +4345,25 @@
       </p:sp>
       <p:sp>
         <p:nvSpPr>
-          <p:cNvPr id="9" name="TextBox 8"/>
-          <p:cNvSpPr txBox="1"/>
-          <p:nvPr/>
-        </p:nvSpPr>
-        <p:spPr>
-          <a:xfrm>
-            <a:off x="1371600" y="2167128"/>
-            <a:ext cx="384048" cy="347472"/>
-          </a:xfrm>
-          <a:prstGeom prst="rect">
-            <a:avLst/>
-          </a:prstGeom>
-          <a:noFill/>
-        </p:spPr>
-        <p:txBody>
-          <a:bodyPr wrap="none">
-            <a:spAutoFit/>
-          </a:bodyPr>
-          <a:lstStyle/>
-          <a:p>
-            <a:pPr algn="ctr">
-              <a:spcAft>
-                <a:spcPts val="800"/>
-              </a:spcAft>
-            </a:pPr>
-            <a:r>
-              <a:rPr sz="1400" b="1">
-                <a:solidFill>
-                  <a:srgbClr val="FFFFFF"/>
-                </a:solidFill>
-                <a:latin typeface="Microsoft YaHei"/>
-              </a:rPr>
-              <a:t>2</a:t>
-            </a:r>
-          </a:p>
-        </p:txBody>
-      </p:sp>
-      <p:sp>
-        <p:nvSpPr>
-          <p:cNvPr id="10" name="TextBox 9"/>
-          <p:cNvSpPr txBox="1"/>
-          <p:nvPr/>
-        </p:nvSpPr>
-        <p:spPr>
-          <a:xfrm>
-            <a:off x="1920240" y="2130552"/>
-            <a:ext cx="9144000" cy="594360"/>
-          </a:xfrm>
-          <a:prstGeom prst="rect">
-            <a:avLst/>
-          </a:prstGeom>
-          <a:noFill/>
-        </p:spPr>
-        <p:txBody>
-          <a:bodyPr wrap="none">
-            <a:spAutoFit/>
-          </a:bodyPr>
-          <a:lstStyle/>
-          <a:p>
-            <a:pPr algn="l">
-              <a:spcAft>
-                <a:spcPts val="800"/>
-              </a:spcAft>
-            </a:pPr>
-            <a:r>
-              <a:rPr sz="2400" b="1">
-                <a:solidFill>
-                  <a:srgbClr val="784696"/>
-                </a:solidFill>
-                <a:latin typeface="Microsoft YaHei"/>
-              </a:rPr>
-              <a:t>童话：</a:t>
-            </a:r>
-            <a:r>
-              <a:rPr sz="2400" b="0">
-                <a:solidFill>
-                  <a:srgbClr val="321E46"/>
-                </a:solidFill>
-                <a:latin typeface="Microsoft YaHei"/>
-              </a:rPr>
-              <a:t>想象依据：生活经验；表现：夸张反讽</a:t>
-            </a:r>
-          </a:p>
-        </p:txBody>
-      </p:sp>
-      <p:sp>
-        <p:nvSpPr>
-          <p:cNvPr id="11" name="Oval 10"/>
+          <p:cNvPr id="10" name="Rounded Rectangle 9"/>
           <p:cNvSpPr/>
           <p:nvPr/>
         </p:nvSpPr>
         <p:spPr>
           <a:xfrm>
-            <a:off x="1371600" y="2834640"/>
-            <a:ext cx="384048" cy="384048"/>
-          </a:xfrm>
-          <a:prstGeom prst="ellipse">
+            <a:off x="1249984" y="1810512"/>
+            <a:ext cx="9692640" cy="3319272"/>
+          </a:xfrm>
+          <a:prstGeom prst="roundRect">
             <a:avLst/>
           </a:prstGeom>
           <a:solidFill>
-            <a:srgbClr val="E66496"/>
+            <a:srgbClr val="FFFAFF"/>
           </a:solidFill>
-          <a:ln>
-            <a:noFill/>
+          <a:ln w="19050">
+            <a:solidFill>
+              <a:srgbClr val="64C8DC"/>
+            </a:solidFill>
           </a:ln>
         </p:spPr>
         <p:style>
@@ -5003,14 +4390,14 @@
       </p:sp>
       <p:sp>
         <p:nvSpPr>
-          <p:cNvPr id="12" name="TextBox 11"/>
+          <p:cNvPr id="11" name="TextBox 10"/>
           <p:cNvSpPr txBox="1"/>
           <p:nvPr/>
         </p:nvSpPr>
         <p:spPr>
           <a:xfrm>
-            <a:off x="1371600" y="2852928"/>
-            <a:ext cx="384048" cy="347472"/>
+            <a:off x="1463040" y="1920240"/>
+            <a:ext cx="2103120" cy="502920"/>
           </a:xfrm>
           <a:prstGeom prst="rect">
             <a:avLst/>
@@ -5023,33 +4410,33 @@
           </a:bodyPr>
           <a:lstStyle/>
           <a:p>
-            <a:pPr algn="ctr">
+            <a:pPr algn="r">
               <a:spcAft>
-                <a:spcPts val="800"/>
+                <a:spcPts val="1000"/>
               </a:spcAft>
             </a:pPr>
             <a:r>
-              <a:rPr sz="1400" b="1">
+              <a:rPr sz="2200" b="1">
                 <a:solidFill>
-                  <a:srgbClr val="FFFFFF"/>
+                  <a:srgbClr val="E65096"/>
                 </a:solidFill>
                 <a:latin typeface="Microsoft YaHei"/>
               </a:rPr>
-              <a:t>3</a:t>
-            </a:r>
-          </a:p>
-        </p:txBody>
-      </p:sp>
-      <p:sp>
-        <p:nvSpPr>
-          <p:cNvPr id="13" name="TextBox 12"/>
+              <a:t>联想</a:t>
+            </a:r>
+          </a:p>
+        </p:txBody>
+      </p:sp>
+      <p:sp>
+        <p:nvSpPr>
+          <p:cNvPr id="12" name="TextBox 11"/>
           <p:cNvSpPr txBox="1"/>
           <p:nvPr/>
         </p:nvSpPr>
         <p:spPr>
           <a:xfrm>
-            <a:off x="1920240" y="2816352"/>
-            <a:ext cx="9144000" cy="594360"/>
+            <a:off x="3749039" y="1920240"/>
+            <a:ext cx="7132320" cy="685800"/>
           </a:xfrm>
           <a:prstGeom prst="rect">
             <a:avLst/>
@@ -5064,83 +4451,70 @@
           <a:p>
             <a:pPr algn="l">
               <a:spcAft>
-                <a:spcPts val="800"/>
+                <a:spcPts val="1000"/>
               </a:spcAft>
             </a:pPr>
             <a:r>
-              <a:rPr sz="2400" b="1">
+              <a:rPr sz="2200" b="0">
                 <a:solidFill>
-                  <a:srgbClr val="784696"/>
+                  <a:srgbClr val="46325A"/>
                 </a:solidFill>
                 <a:latin typeface="Microsoft YaHei"/>
               </a:rPr>
-              <a:t>神话：</a:t>
-            </a:r>
-            <a:r>
-              <a:rPr sz="2400" b="0">
+              <a:t>由一事物想到另一事物（街灯→明星，因形状相似）</a:t>
+            </a:r>
+          </a:p>
+        </p:txBody>
+      </p:sp>
+      <p:sp>
+        <p:nvSpPr>
+          <p:cNvPr id="13" name="TextBox 12"/>
+          <p:cNvSpPr txBox="1"/>
+          <p:nvPr/>
+        </p:nvSpPr>
+        <p:spPr>
+          <a:xfrm>
+            <a:off x="1463040" y="2670048"/>
+            <a:ext cx="2103120" cy="502920"/>
+          </a:xfrm>
+          <a:prstGeom prst="rect">
+            <a:avLst/>
+          </a:prstGeom>
+          <a:noFill/>
+        </p:spPr>
+        <p:txBody>
+          <a:bodyPr wrap="none">
+            <a:spAutoFit/>
+          </a:bodyPr>
+          <a:lstStyle/>
+          <a:p>
+            <a:pPr algn="r">
+              <a:spcAft>
+                <a:spcPts val="1000"/>
+              </a:spcAft>
+            </a:pPr>
+            <a:r>
+              <a:rPr sz="2200" b="1">
                 <a:solidFill>
-                  <a:srgbClr val="321E46"/>
+                  <a:srgbClr val="E65096"/>
                 </a:solidFill>
                 <a:latin typeface="Microsoft YaHei"/>
               </a:rPr>
-              <a:t>想象依据：古籍传说；表现：创世画面</a:t>
-            </a:r>
-          </a:p>
-        </p:txBody>
-      </p:sp>
-      <p:sp>
-        <p:nvSpPr>
-          <p:cNvPr id="14" name="Oval 13"/>
-          <p:cNvSpPr/>
-          <p:nvPr/>
-        </p:nvSpPr>
-        <p:spPr>
-          <a:xfrm>
-            <a:off x="1371600" y="3520440"/>
-            <a:ext cx="384048" cy="384048"/>
-          </a:xfrm>
-          <a:prstGeom prst="ellipse">
-            <a:avLst/>
-          </a:prstGeom>
-          <a:solidFill>
-            <a:srgbClr val="E66496"/>
-          </a:solidFill>
-          <a:ln>
-            <a:noFill/>
-          </a:ln>
-        </p:spPr>
-        <p:style>
-          <a:lnRef idx="1">
-            <a:schemeClr val="accent1"/>
-          </a:lnRef>
-          <a:fillRef idx="3">
-            <a:schemeClr val="accent1"/>
-          </a:fillRef>
-          <a:effectRef idx="2">
-            <a:schemeClr val="accent1"/>
-          </a:effectRef>
-          <a:fontRef idx="minor">
-            <a:schemeClr val="lt1"/>
-          </a:fontRef>
-        </p:style>
-        <p:txBody>
-          <a:bodyPr rtlCol="0" anchor="ctr"/>
-          <a:lstStyle/>
-          <a:p>
-            <a:pPr algn="ctr"/>
-          </a:p>
-        </p:txBody>
-      </p:sp>
-      <p:sp>
-        <p:nvSpPr>
-          <p:cNvPr id="15" name="TextBox 14"/>
+              <a:t>想象</a:t>
+            </a:r>
+          </a:p>
+        </p:txBody>
+      </p:sp>
+      <p:sp>
+        <p:nvSpPr>
+          <p:cNvPr id="14" name="TextBox 13"/>
           <p:cNvSpPr txBox="1"/>
           <p:nvPr/>
         </p:nvSpPr>
         <p:spPr>
           <a:xfrm>
-            <a:off x="1371600" y="3538728"/>
-            <a:ext cx="384048" cy="347472"/>
+            <a:off x="3749039" y="2670048"/>
+            <a:ext cx="7132320" cy="685800"/>
           </a:xfrm>
           <a:prstGeom prst="rect">
             <a:avLst/>
@@ -5153,33 +4527,33 @@
           </a:bodyPr>
           <a:lstStyle/>
           <a:p>
-            <a:pPr algn="ctr">
+            <a:pPr algn="l">
               <a:spcAft>
-                <a:spcPts val="800"/>
+                <a:spcPts val="1000"/>
               </a:spcAft>
             </a:pPr>
             <a:r>
-              <a:rPr sz="1400" b="1">
+              <a:rPr sz="2200" b="0">
                 <a:solidFill>
-                  <a:srgbClr val="FFFFFF"/>
+                  <a:srgbClr val="46325A"/>
                 </a:solidFill>
                 <a:latin typeface="Microsoft YaHei"/>
               </a:rPr>
-              <a:t>4</a:t>
-            </a:r>
-          </a:p>
-        </p:txBody>
-      </p:sp>
-      <p:sp>
-        <p:nvSpPr>
-          <p:cNvPr id="16" name="TextBox 15"/>
+              <a:t>在已有材料上创造新形象（天上的街市、牛郎织女骑牛）</a:t>
+            </a:r>
+          </a:p>
+        </p:txBody>
+      </p:sp>
+      <p:sp>
+        <p:nvSpPr>
+          <p:cNvPr id="15" name="TextBox 14"/>
           <p:cNvSpPr txBox="1"/>
           <p:nvPr/>
         </p:nvSpPr>
         <p:spPr>
           <a:xfrm>
-            <a:off x="1920240" y="3502152"/>
-            <a:ext cx="9144000" cy="594360"/>
+            <a:off x="1463040" y="3419856"/>
+            <a:ext cx="2103120" cy="502920"/>
           </a:xfrm>
           <a:prstGeom prst="rect">
             <a:avLst/>
@@ -5192,28 +4566,136 @@
           </a:bodyPr>
           <a:lstStyle/>
           <a:p>
-            <a:pPr algn="l">
+            <a:pPr algn="r">
               <a:spcAft>
-                <a:spcPts val="800"/>
+                <a:spcPts val="1000"/>
               </a:spcAft>
             </a:pPr>
             <a:r>
-              <a:rPr sz="2400" b="1">
+              <a:rPr sz="2200" b="1">
                 <a:solidFill>
-                  <a:srgbClr val="784696"/>
+                  <a:srgbClr val="E65096"/>
                 </a:solidFill>
                 <a:latin typeface="Microsoft YaHei"/>
               </a:rPr>
-              <a:t>寓言：</a:t>
-            </a:r>
-            <a:r>
-              <a:rPr sz="2400" b="0">
+              <a:t>写作要求</a:t>
+            </a:r>
+          </a:p>
+        </p:txBody>
+      </p:sp>
+      <p:sp>
+        <p:nvSpPr>
+          <p:cNvPr id="16" name="TextBox 15"/>
+          <p:cNvSpPr txBox="1"/>
+          <p:nvPr/>
+        </p:nvSpPr>
+        <p:spPr>
+          <a:xfrm>
+            <a:off x="3749039" y="3419856"/>
+            <a:ext cx="7132320" cy="685800"/>
+          </a:xfrm>
+          <a:prstGeom prst="rect">
+            <a:avLst/>
+          </a:prstGeom>
+          <a:noFill/>
+        </p:spPr>
+        <p:txBody>
+          <a:bodyPr wrap="none">
+            <a:spAutoFit/>
+          </a:bodyPr>
+          <a:lstStyle/>
+          <a:p>
+            <a:pPr algn="l">
+              <a:spcAft>
+                <a:spcPts val="1000"/>
+              </a:spcAft>
+            </a:pPr>
+            <a:r>
+              <a:rPr sz="2200" b="0">
                 <a:solidFill>
-                  <a:srgbClr val="321E46"/>
+                  <a:srgbClr val="46325A"/>
                 </a:solidFill>
                 <a:latin typeface="Microsoft YaHei"/>
               </a:rPr>
-              <a:t>想象依据：生活现象；表现：拟人故事</a:t>
+              <a:t>有依据、合逻辑、有新意</a:t>
+            </a:r>
+          </a:p>
+        </p:txBody>
+      </p:sp>
+      <p:sp>
+        <p:nvSpPr>
+          <p:cNvPr id="17" name="TextBox 16"/>
+          <p:cNvSpPr txBox="1"/>
+          <p:nvPr/>
+        </p:nvSpPr>
+        <p:spPr>
+          <a:xfrm>
+            <a:off x="1463040" y="4169664"/>
+            <a:ext cx="2103120" cy="502920"/>
+          </a:xfrm>
+          <a:prstGeom prst="rect">
+            <a:avLst/>
+          </a:prstGeom>
+          <a:noFill/>
+        </p:spPr>
+        <p:txBody>
+          <a:bodyPr wrap="none">
+            <a:spAutoFit/>
+          </a:bodyPr>
+          <a:lstStyle/>
+          <a:p>
+            <a:pPr algn="r">
+              <a:spcAft>
+                <a:spcPts val="1000"/>
+              </a:spcAft>
+            </a:pPr>
+            <a:r>
+              <a:rPr sz="2200" b="1">
+                <a:solidFill>
+                  <a:srgbClr val="E65096"/>
+                </a:solidFill>
+                <a:latin typeface="Microsoft YaHei"/>
+              </a:rPr>
+              <a:t>创作路径</a:t>
+            </a:r>
+          </a:p>
+        </p:txBody>
+      </p:sp>
+      <p:sp>
+        <p:nvSpPr>
+          <p:cNvPr id="18" name="TextBox 17"/>
+          <p:cNvSpPr txBox="1"/>
+          <p:nvPr/>
+        </p:nvSpPr>
+        <p:spPr>
+          <a:xfrm>
+            <a:off x="3749039" y="4169664"/>
+            <a:ext cx="7132320" cy="685800"/>
+          </a:xfrm>
+          <a:prstGeom prst="rect">
+            <a:avLst/>
+          </a:prstGeom>
+          <a:noFill/>
+        </p:spPr>
+        <p:txBody>
+          <a:bodyPr wrap="none">
+            <a:spAutoFit/>
+          </a:bodyPr>
+          <a:lstStyle/>
+          <a:p>
+            <a:pPr algn="l">
+              <a:spcAft>
+                <a:spcPts val="1000"/>
+              </a:spcAft>
+            </a:pPr>
+            <a:r>
+              <a:rPr sz="2200" b="0">
+                <a:solidFill>
+                  <a:srgbClr val="46325A"/>
+                </a:solidFill>
+                <a:latin typeface="Microsoft YaHei"/>
+              </a:rPr>
+              <a:t>触发点→联想链→情节转折→表达主题</a:t>
             </a:r>
           </a:p>
         </p:txBody>
@@ -5238,7 +4720,7 @@
       <p:grpSpPr/>
       <p:pic>
         <p:nvPicPr>
-          <p:cNvPr id="2" name="Picture 1" descr="bg_show.png"/>
+          <p:cNvPr id="2" name="Picture 1" descr="bg_final.png"/>
           <p:cNvPicPr>
             <a:picLocks noChangeAspect="1"/>
           </p:cNvPicPr>
@@ -5275,9 +4757,9 @@
             <a:avLst/>
           </a:prstGeom>
           <a:noFill/>
-          <a:ln w="25400">
+          <a:ln w="31750">
             <a:solidFill>
-              <a:srgbClr val="784696"/>
+              <a:srgbClr val="B464B4"/>
             </a:solidFill>
           </a:ln>
         </p:spPr>
@@ -5303,61 +4785,70 @@
           </a:p>
         </p:txBody>
       </p:sp>
-      <p:sp>
-        <p:nvSpPr>
-          <p:cNvPr id="4" name="TextBox 3"/>
-          <p:cNvSpPr txBox="1"/>
-          <p:nvPr/>
-        </p:nvSpPr>
-        <p:spPr>
-          <a:xfrm>
-            <a:off x="2743200" y="548640"/>
-            <a:ext cx="6675120" cy="731520"/>
-          </a:xfrm>
-          <a:prstGeom prst="rect">
-            <a:avLst/>
-          </a:prstGeom>
-          <a:noFill/>
-        </p:spPr>
-        <p:txBody>
-          <a:bodyPr wrap="none">
-            <a:spAutoFit/>
-          </a:bodyPr>
-          <a:lstStyle/>
-          <a:p>
-            <a:pPr algn="ctr">
-              <a:spcAft>
-                <a:spcPts val="800"/>
-              </a:spcAft>
-            </a:pPr>
-            <a:r>
-              <a:rPr sz="3800" b="1">
-                <a:solidFill>
-                  <a:srgbClr val="784696"/>
-                </a:solidFill>
-                <a:latin typeface="Microsoft YaHei"/>
-              </a:rPr>
-              <a:t>联想与想象</a:t>
-            </a:r>
-          </a:p>
-        </p:txBody>
-      </p:sp>
-      <p:sp>
-        <p:nvSpPr>
-          <p:cNvPr id="5" name="Oval 4"/>
+      <p:pic>
+        <p:nvPicPr>
+          <p:cNvPr id="4" name="Picture 3" descr="corner_final_tl.png"/>
+          <p:cNvPicPr>
+            <a:picLocks noChangeAspect="1"/>
+          </p:cNvPicPr>
+          <p:nvPr/>
+        </p:nvPicPr>
+        <p:blipFill>
+          <a:blip r:embed="rId3"/>
+          <a:stretch>
+            <a:fillRect/>
+          </a:stretch>
+        </p:blipFill>
+        <p:spPr>
+          <a:xfrm>
+            <a:off x="-45720" y="-45720"/>
+            <a:ext cx="2011680" cy="2011680"/>
+          </a:xfrm>
+          <a:prstGeom prst="rect">
+            <a:avLst/>
+          </a:prstGeom>
+        </p:spPr>
+      </p:pic>
+      <p:pic>
+        <p:nvPicPr>
+          <p:cNvPr id="5" name="Picture 4" descr="corner_final_tr.png"/>
+          <p:cNvPicPr>
+            <a:picLocks noChangeAspect="1"/>
+          </p:cNvPicPr>
+          <p:nvPr/>
+        </p:nvPicPr>
+        <p:blipFill>
+          <a:blip r:embed="rId4"/>
+          <a:stretch>
+            <a:fillRect/>
+          </a:stretch>
+        </p:blipFill>
+        <p:spPr>
+          <a:xfrm>
+            <a:off x="9875520" y="-45720"/>
+            <a:ext cx="2011680" cy="2011680"/>
+          </a:xfrm>
+          <a:prstGeom prst="rect">
+            <a:avLst/>
+          </a:prstGeom>
+        </p:spPr>
+      </p:pic>
+      <p:sp>
+        <p:nvSpPr>
+          <p:cNvPr id="6" name="Rounded Rectangle 5"/>
           <p:cNvSpPr/>
           <p:nvPr/>
         </p:nvSpPr>
         <p:spPr>
           <a:xfrm>
-            <a:off x="1371600" y="1463040"/>
-            <a:ext cx="384048" cy="384048"/>
-          </a:xfrm>
-          <a:prstGeom prst="ellipse">
+            <a:off x="4953304" y="502920"/>
+            <a:ext cx="2286000" cy="411480"/>
+          </a:xfrm>
+          <a:prstGeom prst="roundRect">
             <a:avLst/>
           </a:prstGeom>
           <a:solidFill>
-            <a:srgbClr val="E66496"/>
+            <a:srgbClr val="64C8DC"/>
           </a:solidFill>
           <a:ln>
             <a:noFill/>
@@ -5387,14 +4878,14 @@
       </p:sp>
       <p:sp>
         <p:nvSpPr>
-          <p:cNvPr id="6" name="TextBox 5"/>
+          <p:cNvPr id="7" name="TextBox 6"/>
           <p:cNvSpPr txBox="1"/>
           <p:nvPr/>
         </p:nvSpPr>
         <p:spPr>
           <a:xfrm>
-            <a:off x="1371600" y="1481328"/>
-            <a:ext cx="384048" cy="347472"/>
+            <a:off x="4953304" y="521208"/>
+            <a:ext cx="2286000" cy="384048"/>
           </a:xfrm>
           <a:prstGeom prst="rect">
             <a:avLst/>
@@ -5409,31 +4900,31 @@
           <a:p>
             <a:pPr algn="ctr">
               <a:spcAft>
-                <a:spcPts val="800"/>
+                <a:spcPts val="1000"/>
               </a:spcAft>
             </a:pPr>
             <a:r>
-              <a:rPr sz="1400" b="1">
+              <a:rPr sz="1800" b="1">
                 <a:solidFill>
-                  <a:srgbClr val="FFFFFF"/>
+                  <a:srgbClr val="46325A"/>
                 </a:solidFill>
                 <a:latin typeface="Microsoft YaHei"/>
               </a:rPr>
-              <a:t>1</a:t>
-            </a:r>
-          </a:p>
-        </p:txBody>
-      </p:sp>
-      <p:sp>
-        <p:nvSpPr>
-          <p:cNvPr id="7" name="TextBox 6"/>
+              <a:t>策展笔记</a:t>
+            </a:r>
+          </a:p>
+        </p:txBody>
+      </p:sp>
+      <p:sp>
+        <p:nvSpPr>
+          <p:cNvPr id="8" name="TextBox 7"/>
           <p:cNvSpPr txBox="1"/>
           <p:nvPr/>
         </p:nvSpPr>
         <p:spPr>
           <a:xfrm>
-            <a:off x="1920240" y="1444752"/>
-            <a:ext cx="9144000" cy="594360"/>
+            <a:off x="1371600" y="1051560"/>
+            <a:ext cx="9418320" cy="822960"/>
           </a:xfrm>
           <a:prstGeom prst="rect">
             <a:avLst/>
@@ -5441,53 +4932,44 @@
           <a:noFill/>
         </p:spPr>
         <p:txBody>
-          <a:bodyPr wrap="none">
+          <a:bodyPr wrap="square">
             <a:spAutoFit/>
           </a:bodyPr>
           <a:lstStyle/>
           <a:p>
-            <a:pPr algn="l">
+            <a:pPr algn="ctr">
               <a:spcAft>
-                <a:spcPts val="800"/>
+                <a:spcPts val="1000"/>
               </a:spcAft>
             </a:pPr>
             <a:r>
-              <a:rPr sz="2400" b="1">
+              <a:rPr sz="3600" b="1">
                 <a:solidFill>
-                  <a:srgbClr val="784696"/>
+                  <a:srgbClr val="E65096"/>
                 </a:solidFill>
                 <a:latin typeface="Microsoft YaHei"/>
               </a:rPr>
-              <a:t>联想：</a:t>
-            </a:r>
-            <a:r>
-              <a:rPr sz="2400" b="0">
-                <a:solidFill>
-                  <a:srgbClr val="321E46"/>
-                </a:solidFill>
-                <a:latin typeface="Microsoft YaHei"/>
-              </a:rPr>
-              <a:t>由一事物想到另一事物（街灯→明星）</a:t>
-            </a:r>
-          </a:p>
-        </p:txBody>
-      </p:sp>
-      <p:sp>
-        <p:nvSpPr>
-          <p:cNvPr id="8" name="Oval 7"/>
+              <a:t>想象说明卡</a:t>
+            </a:r>
+          </a:p>
+        </p:txBody>
+      </p:sp>
+      <p:sp>
+        <p:nvSpPr>
+          <p:cNvPr id="9" name="Rectangle 8"/>
           <p:cNvSpPr/>
           <p:nvPr/>
         </p:nvSpPr>
         <p:spPr>
           <a:xfrm>
-            <a:off x="1371600" y="2148840"/>
-            <a:ext cx="384048" cy="384048"/>
-          </a:xfrm>
-          <a:prstGeom prst="ellipse">
+            <a:off x="3200400" y="1691640"/>
+            <a:ext cx="5760720" cy="27432"/>
+          </a:xfrm>
+          <a:prstGeom prst="rect">
             <a:avLst/>
           </a:prstGeom>
           <a:solidFill>
-            <a:srgbClr val="E66496"/>
+            <a:srgbClr val="64C8DC"/>
           </a:solidFill>
           <a:ln>
             <a:noFill/>
@@ -5517,110 +4999,25 @@
       </p:sp>
       <p:sp>
         <p:nvSpPr>
-          <p:cNvPr id="9" name="TextBox 8"/>
-          <p:cNvSpPr txBox="1"/>
-          <p:nvPr/>
-        </p:nvSpPr>
-        <p:spPr>
-          <a:xfrm>
-            <a:off x="1371600" y="2167128"/>
-            <a:ext cx="384048" cy="347472"/>
-          </a:xfrm>
-          <a:prstGeom prst="rect">
-            <a:avLst/>
-          </a:prstGeom>
-          <a:noFill/>
-        </p:spPr>
-        <p:txBody>
-          <a:bodyPr wrap="none">
-            <a:spAutoFit/>
-          </a:bodyPr>
-          <a:lstStyle/>
-          <a:p>
-            <a:pPr algn="ctr">
-              <a:spcAft>
-                <a:spcPts val="800"/>
-              </a:spcAft>
-            </a:pPr>
-            <a:r>
-              <a:rPr sz="1400" b="1">
-                <a:solidFill>
-                  <a:srgbClr val="FFFFFF"/>
-                </a:solidFill>
-                <a:latin typeface="Microsoft YaHei"/>
-              </a:rPr>
-              <a:t>2</a:t>
-            </a:r>
-          </a:p>
-        </p:txBody>
-      </p:sp>
-      <p:sp>
-        <p:nvSpPr>
-          <p:cNvPr id="10" name="TextBox 9"/>
-          <p:cNvSpPr txBox="1"/>
-          <p:nvPr/>
-        </p:nvSpPr>
-        <p:spPr>
-          <a:xfrm>
-            <a:off x="1920240" y="2130552"/>
-            <a:ext cx="9144000" cy="594360"/>
-          </a:xfrm>
-          <a:prstGeom prst="rect">
-            <a:avLst/>
-          </a:prstGeom>
-          <a:noFill/>
-        </p:spPr>
-        <p:txBody>
-          <a:bodyPr wrap="none">
-            <a:spAutoFit/>
-          </a:bodyPr>
-          <a:lstStyle/>
-          <a:p>
-            <a:pPr algn="l">
-              <a:spcAft>
-                <a:spcPts val="800"/>
-              </a:spcAft>
-            </a:pPr>
-            <a:r>
-              <a:rPr sz="2400" b="1">
-                <a:solidFill>
-                  <a:srgbClr val="784696"/>
-                </a:solidFill>
-                <a:latin typeface="Microsoft YaHei"/>
-              </a:rPr>
-              <a:t>想象：</a:t>
-            </a:r>
-            <a:r>
-              <a:rPr sz="2400" b="0">
-                <a:solidFill>
-                  <a:srgbClr val="321E46"/>
-                </a:solidFill>
-                <a:latin typeface="Microsoft YaHei"/>
-              </a:rPr>
-              <a:t>在已有材料上创造新形象（天上的街市）</a:t>
-            </a:r>
-          </a:p>
-        </p:txBody>
-      </p:sp>
-      <p:sp>
-        <p:nvSpPr>
-          <p:cNvPr id="11" name="Oval 10"/>
+          <p:cNvPr id="10" name="Rounded Rectangle 9"/>
           <p:cNvSpPr/>
           <p:nvPr/>
         </p:nvSpPr>
         <p:spPr>
           <a:xfrm>
-            <a:off x="1371600" y="2834640"/>
-            <a:ext cx="384048" cy="384048"/>
-          </a:xfrm>
-          <a:prstGeom prst="ellipse">
+            <a:off x="1249984" y="1810512"/>
+            <a:ext cx="9692640" cy="3319272"/>
+          </a:xfrm>
+          <a:prstGeom prst="roundRect">
             <a:avLst/>
           </a:prstGeom>
           <a:solidFill>
-            <a:srgbClr val="E66496"/>
+            <a:srgbClr val="FFFAFF"/>
           </a:solidFill>
-          <a:ln>
-            <a:noFill/>
+          <a:ln w="19050">
+            <a:solidFill>
+              <a:srgbClr val="64C8DC"/>
+            </a:solidFill>
           </a:ln>
         </p:spPr>
         <p:style>
@@ -5647,14 +5044,14 @@
       </p:sp>
       <p:sp>
         <p:nvSpPr>
-          <p:cNvPr id="12" name="TextBox 11"/>
+          <p:cNvPr id="11" name="TextBox 10"/>
           <p:cNvSpPr txBox="1"/>
           <p:nvPr/>
         </p:nvSpPr>
         <p:spPr>
           <a:xfrm>
-            <a:off x="1371600" y="2852928"/>
-            <a:ext cx="384048" cy="347472"/>
+            <a:off x="1463040" y="1920240"/>
+            <a:ext cx="2103120" cy="502920"/>
           </a:xfrm>
           <a:prstGeom prst="rect">
             <a:avLst/>
@@ -5667,33 +5064,33 @@
           </a:bodyPr>
           <a:lstStyle/>
           <a:p>
-            <a:pPr algn="ctr">
+            <a:pPr algn="r">
               <a:spcAft>
-                <a:spcPts val="800"/>
+                <a:spcPts val="1000"/>
               </a:spcAft>
             </a:pPr>
             <a:r>
-              <a:rPr sz="1400" b="1">
+              <a:rPr sz="2200" b="1">
                 <a:solidFill>
-                  <a:srgbClr val="FFFFFF"/>
+                  <a:srgbClr val="E65096"/>
                 </a:solidFill>
                 <a:latin typeface="Microsoft YaHei"/>
               </a:rPr>
-              <a:t>3</a:t>
-            </a:r>
-          </a:p>
-        </p:txBody>
-      </p:sp>
-      <p:sp>
-        <p:nvSpPr>
-          <p:cNvPr id="13" name="TextBox 12"/>
+              <a:t>文本片段</a:t>
+            </a:r>
+          </a:p>
+        </p:txBody>
+      </p:sp>
+      <p:sp>
+        <p:nvSpPr>
+          <p:cNvPr id="12" name="TextBox 11"/>
           <p:cNvSpPr txBox="1"/>
           <p:nvPr/>
         </p:nvSpPr>
         <p:spPr>
           <a:xfrm>
-            <a:off x="1920240" y="2816352"/>
-            <a:ext cx="9144000" cy="594360"/>
+            <a:off x="3749039" y="1920240"/>
+            <a:ext cx="7132320" cy="685800"/>
           </a:xfrm>
           <a:prstGeom prst="rect">
             <a:avLst/>
@@ -5708,83 +5105,70 @@
           <a:p>
             <a:pPr algn="l">
               <a:spcAft>
-                <a:spcPts val="800"/>
+                <a:spcPts val="1000"/>
               </a:spcAft>
             </a:pPr>
             <a:r>
-              <a:rPr sz="2400" b="1">
+              <a:rPr sz="2200" b="0">
                 <a:solidFill>
-                  <a:srgbClr val="784696"/>
+                  <a:srgbClr val="46325A"/>
                 </a:solidFill>
                 <a:latin typeface="Microsoft YaHei"/>
               </a:rPr>
-              <a:t>写作要求：</a:t>
-            </a:r>
-            <a:r>
-              <a:rPr sz="2400" b="0">
+              <a:t>从本单元选一个精彩片段</a:t>
+            </a:r>
+          </a:p>
+        </p:txBody>
+      </p:sp>
+      <p:sp>
+        <p:nvSpPr>
+          <p:cNvPr id="13" name="TextBox 12"/>
+          <p:cNvSpPr txBox="1"/>
+          <p:nvPr/>
+        </p:nvSpPr>
+        <p:spPr>
+          <a:xfrm>
+            <a:off x="1463040" y="2670048"/>
+            <a:ext cx="2103120" cy="502920"/>
+          </a:xfrm>
+          <a:prstGeom prst="rect">
+            <a:avLst/>
+          </a:prstGeom>
+          <a:noFill/>
+        </p:spPr>
+        <p:txBody>
+          <a:bodyPr wrap="none">
+            <a:spAutoFit/>
+          </a:bodyPr>
+          <a:lstStyle/>
+          <a:p>
+            <a:pPr algn="r">
+              <a:spcAft>
+                <a:spcPts val="1000"/>
+              </a:spcAft>
+            </a:pPr>
+            <a:r>
+              <a:rPr sz="2200" b="1">
                 <a:solidFill>
-                  <a:srgbClr val="321E46"/>
+                  <a:srgbClr val="E65096"/>
                 </a:solidFill>
                 <a:latin typeface="Microsoft YaHei"/>
               </a:rPr>
-              <a:t>有依据、合逻辑、有新意</a:t>
-            </a:r>
-          </a:p>
-        </p:txBody>
-      </p:sp>
-      <p:sp>
-        <p:nvSpPr>
-          <p:cNvPr id="14" name="Oval 13"/>
-          <p:cNvSpPr/>
-          <p:nvPr/>
-        </p:nvSpPr>
-        <p:spPr>
-          <a:xfrm>
-            <a:off x="1371600" y="3520440"/>
-            <a:ext cx="384048" cy="384048"/>
-          </a:xfrm>
-          <a:prstGeom prst="ellipse">
-            <a:avLst/>
-          </a:prstGeom>
-          <a:solidFill>
-            <a:srgbClr val="E66496"/>
-          </a:solidFill>
-          <a:ln>
-            <a:noFill/>
-          </a:ln>
-        </p:spPr>
-        <p:style>
-          <a:lnRef idx="1">
-            <a:schemeClr val="accent1"/>
-          </a:lnRef>
-          <a:fillRef idx="3">
-            <a:schemeClr val="accent1"/>
-          </a:fillRef>
-          <a:effectRef idx="2">
-            <a:schemeClr val="accent1"/>
-          </a:effectRef>
-          <a:fontRef idx="minor">
-            <a:schemeClr val="lt1"/>
-          </a:fontRef>
-        </p:style>
-        <p:txBody>
-          <a:bodyPr rtlCol="0" anchor="ctr"/>
-          <a:lstStyle/>
-          <a:p>
-            <a:pPr algn="ctr"/>
-          </a:p>
-        </p:txBody>
-      </p:sp>
-      <p:sp>
-        <p:nvSpPr>
-          <p:cNvPr id="15" name="TextBox 14"/>
+              <a:t>想象依据</a:t>
+            </a:r>
+          </a:p>
+        </p:txBody>
+      </p:sp>
+      <p:sp>
+        <p:nvSpPr>
+          <p:cNvPr id="14" name="TextBox 13"/>
           <p:cNvSpPr txBox="1"/>
           <p:nvPr/>
         </p:nvSpPr>
         <p:spPr>
           <a:xfrm>
-            <a:off x="1371600" y="3538728"/>
-            <a:ext cx="384048" cy="347472"/>
+            <a:off x="3749039" y="2670048"/>
+            <a:ext cx="7132320" cy="685800"/>
           </a:xfrm>
           <a:prstGeom prst="rect">
             <a:avLst/>
@@ -5797,33 +5181,33 @@
           </a:bodyPr>
           <a:lstStyle/>
           <a:p>
-            <a:pPr algn="ctr">
+            <a:pPr algn="l">
               <a:spcAft>
-                <a:spcPts val="800"/>
+                <a:spcPts val="1000"/>
               </a:spcAft>
             </a:pPr>
             <a:r>
-              <a:rPr sz="1400" b="1">
+              <a:rPr sz="2200" b="0">
                 <a:solidFill>
-                  <a:srgbClr val="FFFFFF"/>
+                  <a:srgbClr val="46325A"/>
                 </a:solidFill>
                 <a:latin typeface="Microsoft YaHei"/>
               </a:rPr>
-              <a:t>4</a:t>
-            </a:r>
-          </a:p>
-        </p:txBody>
-      </p:sp>
-      <p:sp>
-        <p:nvSpPr>
-          <p:cNvPr id="16" name="TextBox 15"/>
+              <a:t>它从什么现实经验或材料出发？</a:t>
+            </a:r>
+          </a:p>
+        </p:txBody>
+      </p:sp>
+      <p:sp>
+        <p:nvSpPr>
+          <p:cNvPr id="15" name="TextBox 14"/>
           <p:cNvSpPr txBox="1"/>
           <p:nvPr/>
         </p:nvSpPr>
         <p:spPr>
           <a:xfrm>
-            <a:off x="1920240" y="3502152"/>
-            <a:ext cx="9144000" cy="594360"/>
+            <a:off x="1463040" y="3419856"/>
+            <a:ext cx="2103120" cy="502920"/>
           </a:xfrm>
           <a:prstGeom prst="rect">
             <a:avLst/>
@@ -5836,28 +5220,136 @@
           </a:bodyPr>
           <a:lstStyle/>
           <a:p>
-            <a:pPr algn="l">
+            <a:pPr algn="r">
               <a:spcAft>
-                <a:spcPts val="800"/>
+                <a:spcPts val="1000"/>
               </a:spcAft>
             </a:pPr>
             <a:r>
-              <a:rPr sz="2400" b="1">
+              <a:rPr sz="2200" b="1">
                 <a:solidFill>
-                  <a:srgbClr val="784696"/>
+                  <a:srgbClr val="E65096"/>
                 </a:solidFill>
                 <a:latin typeface="Microsoft YaHei"/>
               </a:rPr>
-              <a:t>创作路径：</a:t>
-            </a:r>
-            <a:r>
-              <a:rPr sz="2400" b="0">
+              <a:t>表现方式</a:t>
+            </a:r>
+          </a:p>
+        </p:txBody>
+      </p:sp>
+      <p:sp>
+        <p:nvSpPr>
+          <p:cNvPr id="16" name="TextBox 15"/>
+          <p:cNvSpPr txBox="1"/>
+          <p:nvPr/>
+        </p:nvSpPr>
+        <p:spPr>
+          <a:xfrm>
+            <a:off x="3749039" y="3419856"/>
+            <a:ext cx="7132320" cy="685800"/>
+          </a:xfrm>
+          <a:prstGeom prst="rect">
+            <a:avLst/>
+          </a:prstGeom>
+          <a:noFill/>
+        </p:spPr>
+        <p:txBody>
+          <a:bodyPr wrap="none">
+            <a:spAutoFit/>
+          </a:bodyPr>
+          <a:lstStyle/>
+          <a:p>
+            <a:pPr algn="l">
+              <a:spcAft>
+                <a:spcPts val="1000"/>
+              </a:spcAft>
+            </a:pPr>
+            <a:r>
+              <a:rPr sz="2200" b="0">
                 <a:solidFill>
-                  <a:srgbClr val="321E46"/>
+                  <a:srgbClr val="46325A"/>
                 </a:solidFill>
                 <a:latin typeface="Microsoft YaHei"/>
               </a:rPr>
-              <a:t>触发点→联想链→情节转折→主题</a:t>
+              <a:t>用了什么手法？（变化/夸张/改写/拟人）</a:t>
+            </a:r>
+          </a:p>
+        </p:txBody>
+      </p:sp>
+      <p:sp>
+        <p:nvSpPr>
+          <p:cNvPr id="17" name="TextBox 16"/>
+          <p:cNvSpPr txBox="1"/>
+          <p:nvPr/>
+        </p:nvSpPr>
+        <p:spPr>
+          <a:xfrm>
+            <a:off x="1463040" y="4169664"/>
+            <a:ext cx="2103120" cy="502920"/>
+          </a:xfrm>
+          <a:prstGeom prst="rect">
+            <a:avLst/>
+          </a:prstGeom>
+          <a:noFill/>
+        </p:spPr>
+        <p:txBody>
+          <a:bodyPr wrap="none">
+            <a:spAutoFit/>
+          </a:bodyPr>
+          <a:lstStyle/>
+          <a:p>
+            <a:pPr algn="r">
+              <a:spcAft>
+                <a:spcPts val="1000"/>
+              </a:spcAft>
+            </a:pPr>
+            <a:r>
+              <a:rPr sz="2200" b="1">
+                <a:solidFill>
+                  <a:srgbClr val="E65096"/>
+                </a:solidFill>
+                <a:latin typeface="Microsoft YaHei"/>
+              </a:rPr>
+              <a:t>现实意味</a:t>
+            </a:r>
+          </a:p>
+        </p:txBody>
+      </p:sp>
+      <p:sp>
+        <p:nvSpPr>
+          <p:cNvPr id="18" name="TextBox 17"/>
+          <p:cNvSpPr txBox="1"/>
+          <p:nvPr/>
+        </p:nvSpPr>
+        <p:spPr>
+          <a:xfrm>
+            <a:off x="3749039" y="4169664"/>
+            <a:ext cx="7132320" cy="685800"/>
+          </a:xfrm>
+          <a:prstGeom prst="rect">
+            <a:avLst/>
+          </a:prstGeom>
+          <a:noFill/>
+        </p:spPr>
+        <p:txBody>
+          <a:bodyPr wrap="none">
+            <a:spAutoFit/>
+          </a:bodyPr>
+          <a:lstStyle/>
+          <a:p>
+            <a:pPr algn="l">
+              <a:spcAft>
+                <a:spcPts val="1000"/>
+              </a:spcAft>
+            </a:pPr>
+            <a:r>
+              <a:rPr sz="2200" b="0">
+                <a:solidFill>
+                  <a:srgbClr val="46325A"/>
+                </a:solidFill>
+                <a:latin typeface="Microsoft YaHei"/>
+              </a:rPr>
+              <a:t>照见了怎样的生活道理？（联系策展主题）</a:t>
             </a:r>
           </a:p>
         </p:txBody>
@@ -5882,7 +5374,7 @@
       <p:grpSpPr/>
       <p:pic>
         <p:nvPicPr>
-          <p:cNvPr id="2" name="Picture 1" descr="bg_show.png"/>
+          <p:cNvPr id="2" name="Picture 1" descr="bg_final.png"/>
           <p:cNvPicPr>
             <a:picLocks noChangeAspect="1"/>
           </p:cNvPicPr>
@@ -5919,9 +5411,9 @@
             <a:avLst/>
           </a:prstGeom>
           <a:noFill/>
-          <a:ln w="25400">
+          <a:ln w="31750">
             <a:solidFill>
-              <a:srgbClr val="784696"/>
+              <a:srgbClr val="B464B4"/>
             </a:solidFill>
           </a:ln>
         </p:spPr>
@@ -5947,61 +5439,70 @@
           </a:p>
         </p:txBody>
       </p:sp>
-      <p:sp>
-        <p:nvSpPr>
-          <p:cNvPr id="4" name="TextBox 3"/>
-          <p:cNvSpPr txBox="1"/>
-          <p:nvPr/>
-        </p:nvSpPr>
-        <p:spPr>
-          <a:xfrm>
-            <a:off x="2743200" y="548640"/>
-            <a:ext cx="6675120" cy="731520"/>
-          </a:xfrm>
-          <a:prstGeom prst="rect">
-            <a:avLst/>
-          </a:prstGeom>
-          <a:noFill/>
-        </p:spPr>
-        <p:txBody>
-          <a:bodyPr wrap="none">
-            <a:spAutoFit/>
-          </a:bodyPr>
-          <a:lstStyle/>
-          <a:p>
-            <a:pPr algn="ctr">
-              <a:spcAft>
-                <a:spcPts val="800"/>
-              </a:spcAft>
-            </a:pPr>
-            <a:r>
-              <a:rPr sz="3800" b="1">
-                <a:solidFill>
-                  <a:srgbClr val="784696"/>
-                </a:solidFill>
-                <a:latin typeface="Microsoft YaHei"/>
-              </a:rPr>
-              <a:t>想象说明卡</a:t>
-            </a:r>
-          </a:p>
-        </p:txBody>
-      </p:sp>
-      <p:sp>
-        <p:nvSpPr>
-          <p:cNvPr id="5" name="Oval 4"/>
+      <p:pic>
+        <p:nvPicPr>
+          <p:cNvPr id="4" name="Picture 3" descr="corner_final_tl.png"/>
+          <p:cNvPicPr>
+            <a:picLocks noChangeAspect="1"/>
+          </p:cNvPicPr>
+          <p:nvPr/>
+        </p:nvPicPr>
+        <p:blipFill>
+          <a:blip r:embed="rId3"/>
+          <a:stretch>
+            <a:fillRect/>
+          </a:stretch>
+        </p:blipFill>
+        <p:spPr>
+          <a:xfrm>
+            <a:off x="-45720" y="-45720"/>
+            <a:ext cx="2011680" cy="2011680"/>
+          </a:xfrm>
+          <a:prstGeom prst="rect">
+            <a:avLst/>
+          </a:prstGeom>
+        </p:spPr>
+      </p:pic>
+      <p:pic>
+        <p:nvPicPr>
+          <p:cNvPr id="5" name="Picture 4" descr="corner_final_tr.png"/>
+          <p:cNvPicPr>
+            <a:picLocks noChangeAspect="1"/>
+          </p:cNvPicPr>
+          <p:nvPr/>
+        </p:nvPicPr>
+        <p:blipFill>
+          <a:blip r:embed="rId4"/>
+          <a:stretch>
+            <a:fillRect/>
+          </a:stretch>
+        </p:blipFill>
+        <p:spPr>
+          <a:xfrm>
+            <a:off x="9875520" y="-45720"/>
+            <a:ext cx="2011680" cy="2011680"/>
+          </a:xfrm>
+          <a:prstGeom prst="rect">
+            <a:avLst/>
+          </a:prstGeom>
+        </p:spPr>
+      </p:pic>
+      <p:sp>
+        <p:nvSpPr>
+          <p:cNvPr id="6" name="Rounded Rectangle 5"/>
           <p:cNvSpPr/>
           <p:nvPr/>
         </p:nvSpPr>
         <p:spPr>
           <a:xfrm>
-            <a:off x="1371600" y="1463040"/>
-            <a:ext cx="384048" cy="384048"/>
-          </a:xfrm>
-          <a:prstGeom prst="ellipse">
+            <a:off x="4953304" y="502920"/>
+            <a:ext cx="2286000" cy="411480"/>
+          </a:xfrm>
+          <a:prstGeom prst="roundRect">
             <a:avLst/>
           </a:prstGeom>
           <a:solidFill>
-            <a:srgbClr val="E66496"/>
+            <a:srgbClr val="64C8DC"/>
           </a:solidFill>
           <a:ln>
             <a:noFill/>
@@ -6031,14 +5532,14 @@
       </p:sp>
       <p:sp>
         <p:nvSpPr>
-          <p:cNvPr id="6" name="TextBox 5"/>
+          <p:cNvPr id="7" name="TextBox 6"/>
           <p:cNvSpPr txBox="1"/>
           <p:nvPr/>
         </p:nvSpPr>
         <p:spPr>
           <a:xfrm>
-            <a:off x="1371600" y="1481328"/>
-            <a:ext cx="384048" cy="347472"/>
+            <a:off x="4953304" y="521208"/>
+            <a:ext cx="2286000" cy="384048"/>
           </a:xfrm>
           <a:prstGeom prst="rect">
             <a:avLst/>
@@ -6053,7 +5554,216 @@
           <a:p>
             <a:pPr algn="ctr">
               <a:spcAft>
-                <a:spcPts val="800"/>
+                <a:spcPts val="1000"/>
+              </a:spcAft>
+            </a:pPr>
+            <a:r>
+              <a:rPr sz="1800" b="1">
+                <a:solidFill>
+                  <a:srgbClr val="46325A"/>
+                </a:solidFill>
+                <a:latin typeface="Microsoft YaHei"/>
+              </a:rPr>
+              <a:t>展示活动</a:t>
+            </a:r>
+          </a:p>
+        </p:txBody>
+      </p:sp>
+      <p:sp>
+        <p:nvSpPr>
+          <p:cNvPr id="8" name="TextBox 7"/>
+          <p:cNvSpPr txBox="1"/>
+          <p:nvPr/>
+        </p:nvSpPr>
+        <p:spPr>
+          <a:xfrm>
+            <a:off x="1371600" y="1051560"/>
+            <a:ext cx="9418320" cy="822960"/>
+          </a:xfrm>
+          <a:prstGeom prst="rect">
+            <a:avLst/>
+          </a:prstGeom>
+          <a:noFill/>
+        </p:spPr>
+        <p:txBody>
+          <a:bodyPr wrap="square">
+            <a:spAutoFit/>
+          </a:bodyPr>
+          <a:lstStyle/>
+          <a:p>
+            <a:pPr algn="ctr">
+              <a:spcAft>
+                <a:spcPts val="1000"/>
+              </a:spcAft>
+            </a:pPr>
+            <a:r>
+              <a:rPr sz="3600" b="1">
+                <a:solidFill>
+                  <a:srgbClr val="E65096"/>
+                </a:solidFill>
+                <a:latin typeface="Microsoft YaHei"/>
+              </a:rPr>
+              <a:t>成果展示要求</a:t>
+            </a:r>
+          </a:p>
+        </p:txBody>
+      </p:sp>
+      <p:sp>
+        <p:nvSpPr>
+          <p:cNvPr id="9" name="Rectangle 8"/>
+          <p:cNvSpPr/>
+          <p:nvPr/>
+        </p:nvSpPr>
+        <p:spPr>
+          <a:xfrm>
+            <a:off x="3200400" y="1691640"/>
+            <a:ext cx="5760720" cy="27432"/>
+          </a:xfrm>
+          <a:prstGeom prst="rect">
+            <a:avLst/>
+          </a:prstGeom>
+          <a:solidFill>
+            <a:srgbClr val="64C8DC"/>
+          </a:solidFill>
+          <a:ln>
+            <a:noFill/>
+          </a:ln>
+        </p:spPr>
+        <p:style>
+          <a:lnRef idx="1">
+            <a:schemeClr val="accent1"/>
+          </a:lnRef>
+          <a:fillRef idx="3">
+            <a:schemeClr val="accent1"/>
+          </a:fillRef>
+          <a:effectRef idx="2">
+            <a:schemeClr val="accent1"/>
+          </a:effectRef>
+          <a:fontRef idx="minor">
+            <a:schemeClr val="lt1"/>
+          </a:fontRef>
+        </p:style>
+        <p:txBody>
+          <a:bodyPr rtlCol="0" anchor="ctr"/>
+          <a:lstStyle/>
+          <a:p>
+            <a:pPr algn="ctr"/>
+          </a:p>
+        </p:txBody>
+      </p:sp>
+      <p:sp>
+        <p:nvSpPr>
+          <p:cNvPr id="10" name="Rounded Rectangle 9"/>
+          <p:cNvSpPr/>
+          <p:nvPr/>
+        </p:nvSpPr>
+        <p:spPr>
+          <a:xfrm>
+            <a:off x="1295704" y="1737360"/>
+            <a:ext cx="9601200" cy="2112264"/>
+          </a:xfrm>
+          <a:prstGeom prst="roundRect">
+            <a:avLst/>
+          </a:prstGeom>
+          <a:solidFill>
+            <a:srgbClr val="FFFAFF"/>
+          </a:solidFill>
+          <a:ln w="19050">
+            <a:solidFill>
+              <a:srgbClr val="64C8DC"/>
+            </a:solidFill>
+          </a:ln>
+        </p:spPr>
+        <p:style>
+          <a:lnRef idx="1">
+            <a:schemeClr val="accent1"/>
+          </a:lnRef>
+          <a:fillRef idx="3">
+            <a:schemeClr val="accent1"/>
+          </a:fillRef>
+          <a:effectRef idx="2">
+            <a:schemeClr val="accent1"/>
+          </a:effectRef>
+          <a:fontRef idx="minor">
+            <a:schemeClr val="lt1"/>
+          </a:fontRef>
+        </p:style>
+        <p:txBody>
+          <a:bodyPr rtlCol="0" anchor="ctr"/>
+          <a:lstStyle/>
+          <a:p>
+            <a:pPr algn="ctr"/>
+          </a:p>
+        </p:txBody>
+      </p:sp>
+      <p:sp>
+        <p:nvSpPr>
+          <p:cNvPr id="11" name="Oval 10"/>
+          <p:cNvSpPr/>
+          <p:nvPr/>
+        </p:nvSpPr>
+        <p:spPr>
+          <a:xfrm>
+            <a:off x="2621584" y="1920240"/>
+            <a:ext cx="347472" cy="347472"/>
+          </a:xfrm>
+          <a:prstGeom prst="ellipse">
+            <a:avLst/>
+          </a:prstGeom>
+          <a:solidFill>
+            <a:srgbClr val="E65096"/>
+          </a:solidFill>
+          <a:ln>
+            <a:noFill/>
+          </a:ln>
+        </p:spPr>
+        <p:style>
+          <a:lnRef idx="1">
+            <a:schemeClr val="accent1"/>
+          </a:lnRef>
+          <a:fillRef idx="3">
+            <a:schemeClr val="accent1"/>
+          </a:fillRef>
+          <a:effectRef idx="2">
+            <a:schemeClr val="accent1"/>
+          </a:effectRef>
+          <a:fontRef idx="minor">
+            <a:schemeClr val="lt1"/>
+          </a:fontRef>
+        </p:style>
+        <p:txBody>
+          <a:bodyPr rtlCol="0" anchor="ctr"/>
+          <a:lstStyle/>
+          <a:p>
+            <a:pPr algn="ctr"/>
+          </a:p>
+        </p:txBody>
+      </p:sp>
+      <p:sp>
+        <p:nvSpPr>
+          <p:cNvPr id="12" name="TextBox 11"/>
+          <p:cNvSpPr txBox="1"/>
+          <p:nvPr/>
+        </p:nvSpPr>
+        <p:spPr>
+          <a:xfrm>
+            <a:off x="2621584" y="1938528"/>
+            <a:ext cx="347472" cy="329184"/>
+          </a:xfrm>
+          <a:prstGeom prst="rect">
+            <a:avLst/>
+          </a:prstGeom>
+          <a:noFill/>
+        </p:spPr>
+        <p:txBody>
+          <a:bodyPr wrap="none">
+            <a:spAutoFit/>
+          </a:bodyPr>
+          <a:lstStyle/>
+          <a:p>
+            <a:pPr algn="ctr">
+              <a:spcAft>
+                <a:spcPts val="1000"/>
               </a:spcAft>
             </a:pPr>
             <a:r>
@@ -6070,14 +5780,14 @@
       </p:sp>
       <p:sp>
         <p:nvSpPr>
-          <p:cNvPr id="7" name="TextBox 6"/>
+          <p:cNvPr id="13" name="TextBox 12"/>
           <p:cNvSpPr txBox="1"/>
           <p:nvPr/>
         </p:nvSpPr>
         <p:spPr>
           <a:xfrm>
-            <a:off x="1920240" y="1444752"/>
-            <a:ext cx="9144000" cy="594360"/>
+            <a:off x="3078784" y="1901952"/>
+            <a:ext cx="7863840" cy="457200"/>
           </a:xfrm>
           <a:prstGeom prst="rect">
             <a:avLst/>
@@ -6092,46 +5802,37 @@
           <a:p>
             <a:pPr algn="l">
               <a:spcAft>
-                <a:spcPts val="800"/>
+                <a:spcPts val="1000"/>
               </a:spcAft>
             </a:pPr>
             <a:r>
-              <a:rPr sz="2400" b="1">
+              <a:rPr sz="2400" b="0">
                 <a:solidFill>
-                  <a:srgbClr val="784696"/>
+                  <a:srgbClr val="46325A"/>
                 </a:solidFill>
                 <a:latin typeface="Microsoft YaHei"/>
               </a:rPr>
-              <a:t>文本片段：</a:t>
-            </a:r>
-            <a:r>
-              <a:rPr sz="2400" b="0">
-                <a:solidFill>
-                  <a:srgbClr val="321E46"/>
-                </a:solidFill>
-                <a:latin typeface="Microsoft YaHei"/>
-              </a:rPr>
-              <a:t>从本单元选一个精彩片段</a:t>
-            </a:r>
-          </a:p>
-        </p:txBody>
-      </p:sp>
-      <p:sp>
-        <p:nvSpPr>
-          <p:cNvPr id="8" name="Oval 7"/>
+              <a:t>布展：说明卡+创作作品，附「请看我如何从文本出发」</a:t>
+            </a:r>
+          </a:p>
+        </p:txBody>
+      </p:sp>
+      <p:sp>
+        <p:nvSpPr>
+          <p:cNvPr id="14" name="Oval 13"/>
           <p:cNvSpPr/>
           <p:nvPr/>
         </p:nvSpPr>
         <p:spPr>
           <a:xfrm>
-            <a:off x="1371600" y="2148840"/>
-            <a:ext cx="384048" cy="384048"/>
+            <a:off x="2621584" y="2487168"/>
+            <a:ext cx="347472" cy="347472"/>
           </a:xfrm>
           <a:prstGeom prst="ellipse">
             <a:avLst/>
           </a:prstGeom>
           <a:solidFill>
-            <a:srgbClr val="E66496"/>
+            <a:srgbClr val="E65096"/>
           </a:solidFill>
           <a:ln>
             <a:noFill/>
@@ -6161,14 +5862,14 @@
       </p:sp>
       <p:sp>
         <p:nvSpPr>
-          <p:cNvPr id="9" name="TextBox 8"/>
+          <p:cNvPr id="15" name="TextBox 14"/>
           <p:cNvSpPr txBox="1"/>
           <p:nvPr/>
         </p:nvSpPr>
         <p:spPr>
           <a:xfrm>
-            <a:off x="1371600" y="2167128"/>
-            <a:ext cx="384048" cy="347472"/>
+            <a:off x="2621584" y="2505456"/>
+            <a:ext cx="347472" cy="329184"/>
           </a:xfrm>
           <a:prstGeom prst="rect">
             <a:avLst/>
@@ -6183,7 +5884,7 @@
           <a:p>
             <a:pPr algn="ctr">
               <a:spcAft>
-                <a:spcPts val="800"/>
+                <a:spcPts val="1000"/>
               </a:spcAft>
             </a:pPr>
             <a:r>
@@ -6200,14 +5901,14 @@
       </p:sp>
       <p:sp>
         <p:nvSpPr>
-          <p:cNvPr id="10" name="TextBox 9"/>
+          <p:cNvPr id="16" name="TextBox 15"/>
           <p:cNvSpPr txBox="1"/>
           <p:nvPr/>
         </p:nvSpPr>
         <p:spPr>
           <a:xfrm>
-            <a:off x="1920240" y="2130552"/>
-            <a:ext cx="9144000" cy="594360"/>
+            <a:off x="3078784" y="2468880"/>
+            <a:ext cx="7863840" cy="457200"/>
           </a:xfrm>
           <a:prstGeom prst="rect">
             <a:avLst/>
@@ -6222,46 +5923,37 @@
           <a:p>
             <a:pPr algn="l">
               <a:spcAft>
-                <a:spcPts val="800"/>
+                <a:spcPts val="1000"/>
               </a:spcAft>
             </a:pPr>
             <a:r>
-              <a:rPr sz="2400" b="1">
+              <a:rPr sz="2400" b="0">
                 <a:solidFill>
-                  <a:srgbClr val="784696"/>
+                  <a:srgbClr val="46325A"/>
                 </a:solidFill>
                 <a:latin typeface="Microsoft YaHei"/>
               </a:rPr>
-              <a:t>想象依据：</a:t>
-            </a:r>
-            <a:r>
-              <a:rPr sz="2400" b="0">
-                <a:solidFill>
-                  <a:srgbClr val="321E46"/>
-                </a:solidFill>
-                <a:latin typeface="Microsoft YaHei"/>
-              </a:rPr>
-              <a:t>从什么现实经验或材料出发？</a:t>
-            </a:r>
-          </a:p>
-        </p:txBody>
-      </p:sp>
-      <p:sp>
-        <p:nvSpPr>
-          <p:cNvPr id="11" name="Oval 10"/>
+              <a:t>讲解：30秒依据+60秒亮点+30秒思考</a:t>
+            </a:r>
+          </a:p>
+        </p:txBody>
+      </p:sp>
+      <p:sp>
+        <p:nvSpPr>
+          <p:cNvPr id="17" name="Oval 16"/>
           <p:cNvSpPr/>
           <p:nvPr/>
         </p:nvSpPr>
         <p:spPr>
           <a:xfrm>
-            <a:off x="1371600" y="2834640"/>
-            <a:ext cx="384048" cy="384048"/>
+            <a:off x="2621584" y="3054096"/>
+            <a:ext cx="347472" cy="347472"/>
           </a:xfrm>
           <a:prstGeom prst="ellipse">
             <a:avLst/>
           </a:prstGeom>
           <a:solidFill>
-            <a:srgbClr val="E66496"/>
+            <a:srgbClr val="E65096"/>
           </a:solidFill>
           <a:ln>
             <a:noFill/>
@@ -6291,14 +5983,14 @@
       </p:sp>
       <p:sp>
         <p:nvSpPr>
-          <p:cNvPr id="12" name="TextBox 11"/>
+          <p:cNvPr id="18" name="TextBox 17"/>
           <p:cNvSpPr txBox="1"/>
           <p:nvPr/>
         </p:nvSpPr>
         <p:spPr>
           <a:xfrm>
-            <a:off x="1371600" y="2852928"/>
-            <a:ext cx="384048" cy="347472"/>
+            <a:off x="2621584" y="3072384"/>
+            <a:ext cx="347472" cy="329184"/>
           </a:xfrm>
           <a:prstGeom prst="rect">
             <a:avLst/>
@@ -6313,7 +6005,7 @@
           <a:p>
             <a:pPr algn="ctr">
               <a:spcAft>
-                <a:spcPts val="800"/>
+                <a:spcPts val="1000"/>
               </a:spcAft>
             </a:pPr>
             <a:r>
@@ -6330,14 +6022,14 @@
       </p:sp>
       <p:sp>
         <p:nvSpPr>
-          <p:cNvPr id="13" name="TextBox 12"/>
+          <p:cNvPr id="19" name="TextBox 18"/>
           <p:cNvSpPr txBox="1"/>
           <p:nvPr/>
         </p:nvSpPr>
         <p:spPr>
           <a:xfrm>
-            <a:off x="1920240" y="2816352"/>
-            <a:ext cx="9144000" cy="594360"/>
+            <a:off x="3078784" y="3035808"/>
+            <a:ext cx="7863840" cy="457200"/>
           </a:xfrm>
           <a:prstGeom prst="rect">
             <a:avLst/>
@@ -6352,156 +6044,17 @@
           <a:p>
             <a:pPr algn="l">
               <a:spcAft>
-                <a:spcPts val="800"/>
+                <a:spcPts val="1000"/>
               </a:spcAft>
             </a:pPr>
             <a:r>
-              <a:rPr sz="2400" b="1">
+              <a:rPr sz="2400" b="0">
                 <a:solidFill>
-                  <a:srgbClr val="784696"/>
+                  <a:srgbClr val="46325A"/>
                 </a:solidFill>
                 <a:latin typeface="Microsoft YaHei"/>
               </a:rPr>
-              <a:t>表现方式：</a:t>
-            </a:r>
-            <a:r>
-              <a:rPr sz="2400" b="0">
-                <a:solidFill>
-                  <a:srgbClr val="321E46"/>
-                </a:solidFill>
-                <a:latin typeface="Microsoft YaHei"/>
-              </a:rPr>
-              <a:t>用了什么手法？神奇之处在哪？</a:t>
-            </a:r>
-          </a:p>
-        </p:txBody>
-      </p:sp>
-      <p:sp>
-        <p:nvSpPr>
-          <p:cNvPr id="14" name="Oval 13"/>
-          <p:cNvSpPr/>
-          <p:nvPr/>
-        </p:nvSpPr>
-        <p:spPr>
-          <a:xfrm>
-            <a:off x="1371600" y="3520440"/>
-            <a:ext cx="384048" cy="384048"/>
-          </a:xfrm>
-          <a:prstGeom prst="ellipse">
-            <a:avLst/>
-          </a:prstGeom>
-          <a:solidFill>
-            <a:srgbClr val="E66496"/>
-          </a:solidFill>
-          <a:ln>
-            <a:noFill/>
-          </a:ln>
-        </p:spPr>
-        <p:style>
-          <a:lnRef idx="1">
-            <a:schemeClr val="accent1"/>
-          </a:lnRef>
-          <a:fillRef idx="3">
-            <a:schemeClr val="accent1"/>
-          </a:fillRef>
-          <a:effectRef idx="2">
-            <a:schemeClr val="accent1"/>
-          </a:effectRef>
-          <a:fontRef idx="minor">
-            <a:schemeClr val="lt1"/>
-          </a:fontRef>
-        </p:style>
-        <p:txBody>
-          <a:bodyPr rtlCol="0" anchor="ctr"/>
-          <a:lstStyle/>
-          <a:p>
-            <a:pPr algn="ctr"/>
-          </a:p>
-        </p:txBody>
-      </p:sp>
-      <p:sp>
-        <p:nvSpPr>
-          <p:cNvPr id="15" name="TextBox 14"/>
-          <p:cNvSpPr txBox="1"/>
-          <p:nvPr/>
-        </p:nvSpPr>
-        <p:spPr>
-          <a:xfrm>
-            <a:off x="1371600" y="3538728"/>
-            <a:ext cx="384048" cy="347472"/>
-          </a:xfrm>
-          <a:prstGeom prst="rect">
-            <a:avLst/>
-          </a:prstGeom>
-          <a:noFill/>
-        </p:spPr>
-        <p:txBody>
-          <a:bodyPr wrap="none">
-            <a:spAutoFit/>
-          </a:bodyPr>
-          <a:lstStyle/>
-          <a:p>
-            <a:pPr algn="ctr">
-              <a:spcAft>
-                <a:spcPts val="800"/>
-              </a:spcAft>
-            </a:pPr>
-            <a:r>
-              <a:rPr sz="1400" b="1">
-                <a:solidFill>
-                  <a:srgbClr val="FFFFFF"/>
-                </a:solidFill>
-                <a:latin typeface="Microsoft YaHei"/>
-              </a:rPr>
-              <a:t>4</a:t>
-            </a:r>
-          </a:p>
-        </p:txBody>
-      </p:sp>
-      <p:sp>
-        <p:nvSpPr>
-          <p:cNvPr id="16" name="TextBox 15"/>
-          <p:cNvSpPr txBox="1"/>
-          <p:nvPr/>
-        </p:nvSpPr>
-        <p:spPr>
-          <a:xfrm>
-            <a:off x="1920240" y="3502152"/>
-            <a:ext cx="9144000" cy="594360"/>
-          </a:xfrm>
-          <a:prstGeom prst="rect">
-            <a:avLst/>
-          </a:prstGeom>
-          <a:noFill/>
-        </p:spPr>
-        <p:txBody>
-          <a:bodyPr wrap="none">
-            <a:spAutoFit/>
-          </a:bodyPr>
-          <a:lstStyle/>
-          <a:p>
-            <a:pPr algn="l">
-              <a:spcAft>
-                <a:spcPts val="800"/>
-              </a:spcAft>
-            </a:pPr>
-            <a:r>
-              <a:rPr sz="2400" b="1">
-                <a:solidFill>
-                  <a:srgbClr val="784696"/>
-                </a:solidFill>
-                <a:latin typeface="Microsoft YaHei"/>
-              </a:rPr>
-              <a:t>现实意味：</a:t>
-            </a:r>
-            <a:r>
-              <a:rPr sz="2400" b="0">
-                <a:solidFill>
-                  <a:srgbClr val="321E46"/>
-                </a:solidFill>
-                <a:latin typeface="Microsoft YaHei"/>
-              </a:rPr>
-              <a:t>照见了怎样的生活道理？</a:t>
+              <a:t>评价：投「发现卡」——最有依据 / 最有新意</a:t>
             </a:r>
           </a:p>
         </p:txBody>
@@ -6526,7 +6079,7 @@
       <p:grpSpPr/>
       <p:pic>
         <p:nvPicPr>
-          <p:cNvPr id="2" name="Picture 1" descr="bg_show.png"/>
+          <p:cNvPr id="2" name="Picture 1" descr="bg_final.png"/>
           <p:cNvPicPr>
             <a:picLocks noChangeAspect="1"/>
           </p:cNvPicPr>
@@ -6563,9 +6116,9 @@
             <a:avLst/>
           </a:prstGeom>
           <a:noFill/>
-          <a:ln w="25400">
+          <a:ln w="31750">
             <a:solidFill>
-              <a:srgbClr val="784696"/>
+              <a:srgbClr val="B464B4"/>
             </a:solidFill>
           </a:ln>
         </p:spPr>
@@ -6591,61 +6144,70 @@
           </a:p>
         </p:txBody>
       </p:sp>
-      <p:sp>
-        <p:nvSpPr>
-          <p:cNvPr id="4" name="TextBox 3"/>
-          <p:cNvSpPr txBox="1"/>
-          <p:nvPr/>
-        </p:nvSpPr>
-        <p:spPr>
-          <a:xfrm>
-            <a:off x="2743200" y="548640"/>
-            <a:ext cx="6675120" cy="731520"/>
-          </a:xfrm>
-          <a:prstGeom prst="rect">
-            <a:avLst/>
-          </a:prstGeom>
-          <a:noFill/>
-        </p:spPr>
-        <p:txBody>
-          <a:bodyPr wrap="none">
-            <a:spAutoFit/>
-          </a:bodyPr>
-          <a:lstStyle/>
-          <a:p>
-            <a:pPr algn="ctr">
-              <a:spcAft>
-                <a:spcPts val="800"/>
-              </a:spcAft>
-            </a:pPr>
-            <a:r>
-              <a:rPr sz="3800" b="1">
-                <a:solidFill>
-                  <a:srgbClr val="784696"/>
-                </a:solidFill>
-                <a:latin typeface="Microsoft YaHei"/>
-              </a:rPr>
-              <a:t>成果展示要求</a:t>
-            </a:r>
-          </a:p>
-        </p:txBody>
-      </p:sp>
-      <p:sp>
-        <p:nvSpPr>
-          <p:cNvPr id="5" name="Oval 4"/>
+      <p:pic>
+        <p:nvPicPr>
+          <p:cNvPr id="4" name="Picture 3" descr="corner_final_tl.png"/>
+          <p:cNvPicPr>
+            <a:picLocks noChangeAspect="1"/>
+          </p:cNvPicPr>
+          <p:nvPr/>
+        </p:nvPicPr>
+        <p:blipFill>
+          <a:blip r:embed="rId3"/>
+          <a:stretch>
+            <a:fillRect/>
+          </a:stretch>
+        </p:blipFill>
+        <p:spPr>
+          <a:xfrm>
+            <a:off x="-45720" y="-45720"/>
+            <a:ext cx="2011680" cy="2011680"/>
+          </a:xfrm>
+          <a:prstGeom prst="rect">
+            <a:avLst/>
+          </a:prstGeom>
+        </p:spPr>
+      </p:pic>
+      <p:pic>
+        <p:nvPicPr>
+          <p:cNvPr id="5" name="Picture 4" descr="corner_final_tr.png"/>
+          <p:cNvPicPr>
+            <a:picLocks noChangeAspect="1"/>
+          </p:cNvPicPr>
+          <p:nvPr/>
+        </p:nvPicPr>
+        <p:blipFill>
+          <a:blip r:embed="rId4"/>
+          <a:stretch>
+            <a:fillRect/>
+          </a:stretch>
+        </p:blipFill>
+        <p:spPr>
+          <a:xfrm>
+            <a:off x="9875520" y="-45720"/>
+            <a:ext cx="2011680" cy="2011680"/>
+          </a:xfrm>
+          <a:prstGeom prst="rect">
+            <a:avLst/>
+          </a:prstGeom>
+        </p:spPr>
+      </p:pic>
+      <p:sp>
+        <p:nvSpPr>
+          <p:cNvPr id="6" name="Rounded Rectangle 5"/>
           <p:cNvSpPr/>
           <p:nvPr/>
         </p:nvSpPr>
         <p:spPr>
           <a:xfrm>
-            <a:off x="1371600" y="1463040"/>
-            <a:ext cx="384048" cy="384048"/>
-          </a:xfrm>
-          <a:prstGeom prst="ellipse">
+            <a:off x="4953304" y="502920"/>
+            <a:ext cx="2286000" cy="411480"/>
+          </a:xfrm>
+          <a:prstGeom prst="roundRect">
             <a:avLst/>
           </a:prstGeom>
           <a:solidFill>
-            <a:srgbClr val="E66496"/>
+            <a:srgbClr val="64C8DC"/>
           </a:solidFill>
           <a:ln>
             <a:noFill/>
@@ -6675,14 +6237,14 @@
       </p:sp>
       <p:sp>
         <p:nvSpPr>
-          <p:cNvPr id="6" name="TextBox 5"/>
+          <p:cNvPr id="7" name="TextBox 6"/>
           <p:cNvSpPr txBox="1"/>
           <p:nvPr/>
         </p:nvSpPr>
         <p:spPr>
           <a:xfrm>
-            <a:off x="1371600" y="1481328"/>
-            <a:ext cx="384048" cy="347472"/>
+            <a:off x="4953304" y="521208"/>
+            <a:ext cx="2286000" cy="384048"/>
           </a:xfrm>
           <a:prstGeom prst="rect">
             <a:avLst/>
@@ -6697,31 +6259,31 @@
           <a:p>
             <a:pPr algn="ctr">
               <a:spcAft>
-                <a:spcPts val="800"/>
+                <a:spcPts val="1000"/>
               </a:spcAft>
             </a:pPr>
             <a:r>
-              <a:rPr sz="1400" b="1">
+              <a:rPr sz="1800" b="1">
                 <a:solidFill>
-                  <a:srgbClr val="FFFFFF"/>
+                  <a:srgbClr val="46325A"/>
                 </a:solidFill>
                 <a:latin typeface="Microsoft YaHei"/>
               </a:rPr>
-              <a:t>1</a:t>
-            </a:r>
-          </a:p>
-        </p:txBody>
-      </p:sp>
-      <p:sp>
-        <p:nvSpPr>
-          <p:cNvPr id="7" name="TextBox 6"/>
+              <a:t>总结笔记</a:t>
+            </a:r>
+          </a:p>
+        </p:txBody>
+      </p:sp>
+      <p:sp>
+        <p:nvSpPr>
+          <p:cNvPr id="8" name="TextBox 7"/>
           <p:cNvSpPr txBox="1"/>
           <p:nvPr/>
         </p:nvSpPr>
         <p:spPr>
           <a:xfrm>
-            <a:off x="1920240" y="1444752"/>
-            <a:ext cx="9144000" cy="594360"/>
+            <a:off x="1371600" y="1051560"/>
+            <a:ext cx="9418320" cy="822960"/>
           </a:xfrm>
           <a:prstGeom prst="rect">
             <a:avLst/>
@@ -6729,44 +6291,44 @@
           <a:noFill/>
         </p:spPr>
         <p:txBody>
-          <a:bodyPr wrap="none">
+          <a:bodyPr wrap="square">
             <a:spAutoFit/>
           </a:bodyPr>
           <a:lstStyle/>
           <a:p>
-            <a:pPr algn="l">
+            <a:pPr algn="ctr">
               <a:spcAft>
-                <a:spcPts val="800"/>
+                <a:spcPts val="1000"/>
               </a:spcAft>
             </a:pPr>
             <a:r>
-              <a:rPr sz="2400" b="0">
+              <a:rPr sz="3600" b="1">
                 <a:solidFill>
-                  <a:srgbClr val="321E46"/>
+                  <a:srgbClr val="E65096"/>
                 </a:solidFill>
                 <a:latin typeface="Microsoft YaHei"/>
               </a:rPr>
-              <a:t>布展：说明卡+创作作品</a:t>
-            </a:r>
-          </a:p>
-        </p:txBody>
-      </p:sp>
-      <p:sp>
-        <p:nvSpPr>
-          <p:cNvPr id="8" name="Oval 7"/>
+              <a:t>单元回顾</a:t>
+            </a:r>
+          </a:p>
+        </p:txBody>
+      </p:sp>
+      <p:sp>
+        <p:nvSpPr>
+          <p:cNvPr id="9" name="Rectangle 8"/>
           <p:cNvSpPr/>
           <p:nvPr/>
         </p:nvSpPr>
         <p:spPr>
           <a:xfrm>
-            <a:off x="1371600" y="2148840"/>
-            <a:ext cx="384048" cy="384048"/>
-          </a:xfrm>
-          <a:prstGeom prst="ellipse">
+            <a:off x="3200400" y="1691640"/>
+            <a:ext cx="5760720" cy="27432"/>
+          </a:xfrm>
+          <a:prstGeom prst="rect">
             <a:avLst/>
           </a:prstGeom>
           <a:solidFill>
-            <a:srgbClr val="E66496"/>
+            <a:srgbClr val="64C8DC"/>
           </a:solidFill>
           <a:ln>
             <a:noFill/>
@@ -6796,101 +6358,25 @@
       </p:sp>
       <p:sp>
         <p:nvSpPr>
-          <p:cNvPr id="9" name="TextBox 8"/>
-          <p:cNvSpPr txBox="1"/>
-          <p:nvPr/>
-        </p:nvSpPr>
-        <p:spPr>
-          <a:xfrm>
-            <a:off x="1371600" y="2167128"/>
-            <a:ext cx="384048" cy="347472"/>
-          </a:xfrm>
-          <a:prstGeom prst="rect">
-            <a:avLst/>
-          </a:prstGeom>
-          <a:noFill/>
-        </p:spPr>
-        <p:txBody>
-          <a:bodyPr wrap="none">
-            <a:spAutoFit/>
-          </a:bodyPr>
-          <a:lstStyle/>
-          <a:p>
-            <a:pPr algn="ctr">
-              <a:spcAft>
-                <a:spcPts val="800"/>
-              </a:spcAft>
-            </a:pPr>
-            <a:r>
-              <a:rPr sz="1400" b="1">
-                <a:solidFill>
-                  <a:srgbClr val="FFFFFF"/>
-                </a:solidFill>
-                <a:latin typeface="Microsoft YaHei"/>
-              </a:rPr>
-              <a:t>2</a:t>
-            </a:r>
-          </a:p>
-        </p:txBody>
-      </p:sp>
-      <p:sp>
-        <p:nvSpPr>
-          <p:cNvPr id="10" name="TextBox 9"/>
-          <p:cNvSpPr txBox="1"/>
-          <p:nvPr/>
-        </p:nvSpPr>
-        <p:spPr>
-          <a:xfrm>
-            <a:off x="1920240" y="2130552"/>
-            <a:ext cx="9144000" cy="594360"/>
-          </a:xfrm>
-          <a:prstGeom prst="rect">
-            <a:avLst/>
-          </a:prstGeom>
-          <a:noFill/>
-        </p:spPr>
-        <p:txBody>
-          <a:bodyPr wrap="none">
-            <a:spAutoFit/>
-          </a:bodyPr>
-          <a:lstStyle/>
-          <a:p>
-            <a:pPr algn="l">
-              <a:spcAft>
-                <a:spcPts val="800"/>
-              </a:spcAft>
-            </a:pPr>
-            <a:r>
-              <a:rPr sz="2400" b="0">
-                <a:solidFill>
-                  <a:srgbClr val="321E46"/>
-                </a:solidFill>
-                <a:latin typeface="Microsoft YaHei"/>
-              </a:rPr>
-              <a:t>讲解：30秒依据+60秒亮点+30秒思考</a:t>
-            </a:r>
-          </a:p>
-        </p:txBody>
-      </p:sp>
-      <p:sp>
-        <p:nvSpPr>
-          <p:cNvPr id="11" name="Oval 10"/>
+          <p:cNvPr id="10" name="Rounded Rectangle 9"/>
           <p:cNvSpPr/>
           <p:nvPr/>
         </p:nvSpPr>
         <p:spPr>
           <a:xfrm>
-            <a:off x="1371600" y="2834640"/>
-            <a:ext cx="384048" cy="384048"/>
-          </a:xfrm>
-          <a:prstGeom prst="ellipse">
+            <a:off x="1249984" y="1810512"/>
+            <a:ext cx="9692640" cy="3319272"/>
+          </a:xfrm>
+          <a:prstGeom prst="roundRect">
             <a:avLst/>
           </a:prstGeom>
           <a:solidFill>
-            <a:srgbClr val="E66496"/>
+            <a:srgbClr val="FFFAFF"/>
           </a:solidFill>
-          <a:ln>
-            <a:noFill/>
+          <a:ln w="19050">
+            <a:solidFill>
+              <a:srgbClr val="64C8DC"/>
+            </a:solidFill>
           </a:ln>
         </p:spPr>
         <p:style>
@@ -6917,14 +6403,14 @@
       </p:sp>
       <p:sp>
         <p:nvSpPr>
-          <p:cNvPr id="12" name="TextBox 11"/>
+          <p:cNvPr id="11" name="TextBox 10"/>
           <p:cNvSpPr txBox="1"/>
           <p:nvPr/>
         </p:nvSpPr>
         <p:spPr>
           <a:xfrm>
-            <a:off x="1371600" y="2852928"/>
-            <a:ext cx="384048" cy="347472"/>
+            <a:off x="1463040" y="1920240"/>
+            <a:ext cx="2103120" cy="502920"/>
           </a:xfrm>
           <a:prstGeom prst="rect">
             <a:avLst/>
@@ -6937,33 +6423,33 @@
           </a:bodyPr>
           <a:lstStyle/>
           <a:p>
-            <a:pPr algn="ctr">
+            <a:pPr algn="r">
               <a:spcAft>
-                <a:spcPts val="800"/>
+                <a:spcPts val="1000"/>
               </a:spcAft>
             </a:pPr>
             <a:r>
-              <a:rPr sz="1400" b="1">
+              <a:rPr sz="2200" b="1">
                 <a:solidFill>
-                  <a:srgbClr val="FFFFFF"/>
+                  <a:srgbClr val="E65096"/>
                 </a:solidFill>
                 <a:latin typeface="Microsoft YaHei"/>
               </a:rPr>
-              <a:t>3</a:t>
-            </a:r>
-          </a:p>
-        </p:txBody>
-      </p:sp>
-      <p:sp>
-        <p:nvSpPr>
-          <p:cNvPr id="13" name="TextBox 12"/>
+              <a:t>母题链</a:t>
+            </a:r>
+          </a:p>
+        </p:txBody>
+      </p:sp>
+      <p:sp>
+        <p:nvSpPr>
+          <p:cNvPr id="12" name="TextBox 11"/>
           <p:cNvSpPr txBox="1"/>
           <p:nvPr/>
         </p:nvSpPr>
         <p:spPr>
           <a:xfrm>
-            <a:off x="1920240" y="2816352"/>
-            <a:ext cx="9144000" cy="594360"/>
+            <a:off x="3749039" y="1920240"/>
+            <a:ext cx="7132320" cy="685800"/>
           </a:xfrm>
           <a:prstGeom prst="rect">
             <a:avLst/>
@@ -6978,74 +6464,31 @@
           <a:p>
             <a:pPr algn="l">
               <a:spcAft>
-                <a:spcPts val="800"/>
+                <a:spcPts val="1000"/>
               </a:spcAft>
             </a:pPr>
             <a:r>
-              <a:rPr sz="2400" b="0">
+              <a:rPr sz="2200" b="0">
                 <a:solidFill>
-                  <a:srgbClr val="321E46"/>
+                  <a:srgbClr val="46325A"/>
                 </a:solidFill>
                 <a:latin typeface="Microsoft YaHei"/>
               </a:rPr>
-              <a:t>评价：投「发现卡」——最有依据/最有新意</a:t>
-            </a:r>
-          </a:p>
-        </p:txBody>
-      </p:sp>
-      <p:sp>
-        <p:nvSpPr>
-          <p:cNvPr id="14" name="Oval 13"/>
-          <p:cNvSpPr/>
-          <p:nvPr/>
-        </p:nvSpPr>
-        <p:spPr>
-          <a:xfrm>
-            <a:off x="1371600" y="3520440"/>
-            <a:ext cx="384048" cy="384048"/>
-          </a:xfrm>
-          <a:prstGeom prst="ellipse">
-            <a:avLst/>
-          </a:prstGeom>
-          <a:solidFill>
-            <a:srgbClr val="E66496"/>
-          </a:solidFill>
-          <a:ln>
-            <a:noFill/>
-          </a:ln>
-        </p:spPr>
-        <p:style>
-          <a:lnRef idx="1">
-            <a:schemeClr val="accent1"/>
-          </a:lnRef>
-          <a:fillRef idx="3">
-            <a:schemeClr val="accent1"/>
-          </a:fillRef>
-          <a:effectRef idx="2">
-            <a:schemeClr val="accent1"/>
-          </a:effectRef>
-          <a:fontRef idx="minor">
-            <a:schemeClr val="lt1"/>
-          </a:fontRef>
-        </p:style>
-        <p:txBody>
-          <a:bodyPr rtlCol="0" anchor="ctr"/>
-          <a:lstStyle/>
-          <a:p>
-            <a:pPr algn="ctr"/>
-          </a:p>
-        </p:txBody>
-      </p:sp>
-      <p:sp>
-        <p:nvSpPr>
-          <p:cNvPr id="15" name="TextBox 14"/>
+              <a:t>自由→真实→创造→智慧</a:t>
+            </a:r>
+          </a:p>
+        </p:txBody>
+      </p:sp>
+      <p:sp>
+        <p:nvSpPr>
+          <p:cNvPr id="13" name="TextBox 12"/>
           <p:cNvSpPr txBox="1"/>
           <p:nvPr/>
         </p:nvSpPr>
         <p:spPr>
           <a:xfrm>
-            <a:off x="1371600" y="3538728"/>
-            <a:ext cx="384048" cy="347472"/>
+            <a:off x="1463040" y="2670048"/>
+            <a:ext cx="2103120" cy="502920"/>
           </a:xfrm>
           <a:prstGeom prst="rect">
             <a:avLst/>
@@ -7058,33 +6501,33 @@
           </a:bodyPr>
           <a:lstStyle/>
           <a:p>
-            <a:pPr algn="ctr">
+            <a:pPr algn="r">
               <a:spcAft>
-                <a:spcPts val="800"/>
+                <a:spcPts val="1000"/>
               </a:spcAft>
             </a:pPr>
             <a:r>
-              <a:rPr sz="1400" b="1">
+              <a:rPr sz="2200" b="1">
                 <a:solidFill>
-                  <a:srgbClr val="FFFFFF"/>
+                  <a:srgbClr val="E65096"/>
                 </a:solidFill>
                 <a:latin typeface="Microsoft YaHei"/>
               </a:rPr>
-              <a:t>4</a:t>
-            </a:r>
-          </a:p>
-        </p:txBody>
-      </p:sp>
-      <p:sp>
-        <p:nvSpPr>
-          <p:cNvPr id="16" name="TextBox 15"/>
+              <a:t>核心领悟</a:t>
+            </a:r>
+          </a:p>
+        </p:txBody>
+      </p:sp>
+      <p:sp>
+        <p:nvSpPr>
+          <p:cNvPr id="14" name="TextBox 13"/>
           <p:cNvSpPr txBox="1"/>
           <p:nvPr/>
         </p:nvSpPr>
         <p:spPr>
           <a:xfrm>
-            <a:off x="1920240" y="3502152"/>
-            <a:ext cx="9144000" cy="594360"/>
+            <a:off x="3749039" y="2670048"/>
+            <a:ext cx="7132320" cy="685800"/>
           </a:xfrm>
           <a:prstGeom prst="rect">
             <a:avLst/>
@@ -7099,17 +6542,173 @@
           <a:p>
             <a:pPr algn="l">
               <a:spcAft>
-                <a:spcPts val="800"/>
+                <a:spcPts val="1000"/>
               </a:spcAft>
             </a:pPr>
             <a:r>
-              <a:rPr sz="2400" b="0">
+              <a:rPr sz="2200" b="0">
                 <a:solidFill>
-                  <a:srgbClr val="321E46"/>
+                  <a:srgbClr val="46325A"/>
                 </a:solidFill>
                 <a:latin typeface="Microsoft YaHei"/>
               </a:rPr>
-              <a:t>作业：600字想象作文或5分钟课本剧</a:t>
+              <a:t>想象必须扎根于真实，飞得再高也要落回地面</a:t>
+            </a:r>
+          </a:p>
+        </p:txBody>
+      </p:sp>
+      <p:sp>
+        <p:nvSpPr>
+          <p:cNvPr id="15" name="TextBox 14"/>
+          <p:cNvSpPr txBox="1"/>
+          <p:nvPr/>
+        </p:nvSpPr>
+        <p:spPr>
+          <a:xfrm>
+            <a:off x="1463040" y="3419856"/>
+            <a:ext cx="2103120" cy="502920"/>
+          </a:xfrm>
+          <a:prstGeom prst="rect">
+            <a:avLst/>
+          </a:prstGeom>
+          <a:noFill/>
+        </p:spPr>
+        <p:txBody>
+          <a:bodyPr wrap="none">
+            <a:spAutoFit/>
+          </a:bodyPr>
+          <a:lstStyle/>
+          <a:p>
+            <a:pPr algn="r">
+              <a:spcAft>
+                <a:spcPts val="1000"/>
+              </a:spcAft>
+            </a:pPr>
+            <a:r>
+              <a:rPr sz="2200" b="1">
+                <a:solidFill>
+                  <a:srgbClr val="E65096"/>
+                </a:solidFill>
+                <a:latin typeface="Microsoft YaHei"/>
+              </a:rPr>
+              <a:t>单元作业</a:t>
+            </a:r>
+          </a:p>
+        </p:txBody>
+      </p:sp>
+      <p:sp>
+        <p:nvSpPr>
+          <p:cNvPr id="16" name="TextBox 15"/>
+          <p:cNvSpPr txBox="1"/>
+          <p:nvPr/>
+        </p:nvSpPr>
+        <p:spPr>
+          <a:xfrm>
+            <a:off x="3749039" y="3419856"/>
+            <a:ext cx="7132320" cy="685800"/>
+          </a:xfrm>
+          <a:prstGeom prst="rect">
+            <a:avLst/>
+          </a:prstGeom>
+          <a:noFill/>
+        </p:spPr>
+        <p:txBody>
+          <a:bodyPr wrap="none">
+            <a:spAutoFit/>
+          </a:bodyPr>
+          <a:lstStyle/>
+          <a:p>
+            <a:pPr algn="l">
+              <a:spcAft>
+                <a:spcPts val="1000"/>
+              </a:spcAft>
+            </a:pPr>
+            <a:r>
+              <a:rPr sz="2200" b="0">
+                <a:solidFill>
+                  <a:srgbClr val="46325A"/>
+                </a:solidFill>
+                <a:latin typeface="Microsoft YaHei"/>
+              </a:rPr>
+              <a:t>600字想象作文，或5分钟课本剧脚本</a:t>
+            </a:r>
+          </a:p>
+        </p:txBody>
+      </p:sp>
+      <p:sp>
+        <p:nvSpPr>
+          <p:cNvPr id="17" name="TextBox 16"/>
+          <p:cNvSpPr txBox="1"/>
+          <p:nvPr/>
+        </p:nvSpPr>
+        <p:spPr>
+          <a:xfrm>
+            <a:off x="1463040" y="4169664"/>
+            <a:ext cx="2103120" cy="502920"/>
+          </a:xfrm>
+          <a:prstGeom prst="rect">
+            <a:avLst/>
+          </a:prstGeom>
+          <a:noFill/>
+        </p:spPr>
+        <p:txBody>
+          <a:bodyPr wrap="none">
+            <a:spAutoFit/>
+          </a:bodyPr>
+          <a:lstStyle/>
+          <a:p>
+            <a:pPr algn="r">
+              <a:spcAft>
+                <a:spcPts val="1000"/>
+              </a:spcAft>
+            </a:pPr>
+            <a:r>
+              <a:rPr sz="2200" b="1">
+                <a:solidFill>
+                  <a:srgbClr val="E65096"/>
+                </a:solidFill>
+                <a:latin typeface="Microsoft YaHei"/>
+              </a:rPr>
+              <a:t>要求</a:t>
+            </a:r>
+          </a:p>
+        </p:txBody>
+      </p:sp>
+      <p:sp>
+        <p:nvSpPr>
+          <p:cNvPr id="18" name="TextBox 17"/>
+          <p:cNvSpPr txBox="1"/>
+          <p:nvPr/>
+        </p:nvSpPr>
+        <p:spPr>
+          <a:xfrm>
+            <a:off x="3749039" y="4169664"/>
+            <a:ext cx="7132320" cy="685800"/>
+          </a:xfrm>
+          <a:prstGeom prst="rect">
+            <a:avLst/>
+          </a:prstGeom>
+          <a:noFill/>
+        </p:spPr>
+        <p:txBody>
+          <a:bodyPr wrap="none">
+            <a:spAutoFit/>
+          </a:bodyPr>
+          <a:lstStyle/>
+          <a:p>
+            <a:pPr algn="l">
+              <a:spcAft>
+                <a:spcPts val="1000"/>
+              </a:spcAft>
+            </a:pPr>
+            <a:r>
+              <a:rPr sz="2200" b="0">
+                <a:solidFill>
+                  <a:srgbClr val="46325A"/>
+                </a:solidFill>
+                <a:latin typeface="Microsoft YaHei"/>
+              </a:rPr>
+              <a:t>有依据、合逻辑、有新意，体现策展主题</a:t>
             </a:r>
           </a:p>
         </p:txBody>

</xml_diff>